<commit_message>
Refine repository artwork for a hand-authored methods style
</commit_message>
<xml_diff>
--- a/docs/source/social_preview_editable.pptx
+++ b/docs/source/social_preview_editable.pptx
@@ -2,13 +2,13 @@
 <file path=ppt/presentation.xml><?xml version="1.0" encoding="utf-8"?>
 <p:presentation xmlns:p="http://schemas.openxmlformats.org/presentationml/2006/main">
   <p:sldMasterIdLst>
-    <p:sldMasterId xmlns:r="http://schemas.openxmlformats.org/officeDocument/2006/relationships" id="2147483648" r:id="Rd35b9b4c58474cd6"/>
+    <p:sldMasterId xmlns:r="http://schemas.openxmlformats.org/officeDocument/2006/relationships" id="2147483648" r:id="R6754169e6a1f4450"/>
   </p:sldMasterIdLst>
   <p:notesMasterIdLst>
-    <p:notesMasterId xmlns:r="http://schemas.openxmlformats.org/officeDocument/2006/relationships" r:id="R0a25e1e7ed6d4dc0"/>
+    <p:notesMasterId xmlns:r="http://schemas.openxmlformats.org/officeDocument/2006/relationships" r:id="R1db3c68ecf83447d"/>
   </p:notesMasterIdLst>
   <p:sldIdLst>
-    <p:sldId xmlns:r="http://schemas.openxmlformats.org/officeDocument/2006/relationships" id="256" r:id="R4242c31be908458a"/>
+    <p:sldId xmlns:r="http://schemas.openxmlformats.org/officeDocument/2006/relationships" id="256" r:id="R390bd4febc2a43e5"/>
   </p:sldIdLst>
   <p:sldSz cx="12192000" cy="6096000"/>
   <p:notesSz cx="6858000" cy="9144000"/>
@@ -601,7 +601,7 @@
   </p:cSld>
   <p:clrMap bg1="lt1" tx1="dk1" bg2="lt2" tx2="dk2" accent1="accent1" accent2="accent2" accent3="accent3" accent4="accent4" accent5="accent5" accent6="accent6" hlink="hlink" folHlink="folHlink"/>
   <p:sldLayoutIdLst>
-    <p:sldLayoutId xmlns:r="http://schemas.openxmlformats.org/officeDocument/2006/relationships" id="2147483649" r:id="R9a460c57810d4e74"/>
+    <p:sldLayoutId xmlns:r="http://schemas.openxmlformats.org/officeDocument/2006/relationships" id="2147483649" r:id="R0bba223edf8d45ff"/>
   </p:sldLayoutIdLst>
   <p:txStyles>
     <p:titleStyle>
@@ -1152,7 +1152,7 @@
           <p:cNvPr id="47" name="social-accent-bar">
             <a:extLst xmlns:a="http://schemas.openxmlformats.org/drawingml/2006/main">
               <a:ext uri="{FF2B5EF4-FFF2-40B4-BE49-F238E27FC236}">
-                <a16:creationId xmlns:a16="http://schemas.microsoft.com/office/drawing/2014/main" id="{21FC5200-F0D3-4137-892D-0824970D51FC}"/>
+                <a16:creationId xmlns:a16="http://schemas.microsoft.com/office/drawing/2014/main" id="{97382E73-F49D-4DB2-A50D-D6D841A78FA7}"/>
               </a:ext>
             </a:extLst>
           </p:cNvPr>
@@ -1164,7 +1164,7 @@
         <p:spPr>
           <a:xfrm xmlns:a="http://schemas.openxmlformats.org/drawingml/2006/main" rot="0">
             <a:off x="0" y="0"/>
-            <a:ext cx="209550" cy="6096000"/>
+            <a:ext cx="133350" cy="6096000"/>
           </a:xfrm>
           <a:prstGeom xmlns:a="http://schemas.openxmlformats.org/drawingml/2006/main" prst="rect">
             <a:avLst/>
@@ -1183,7 +1183,7 @@
           <p:cNvPr id="2" name="social-eyebrow">
             <a:extLst xmlns:a="http://schemas.openxmlformats.org/drawingml/2006/main">
               <a:ext uri="{FF2B5EF4-FFF2-40B4-BE49-F238E27FC236}">
-                <a16:creationId xmlns:a16="http://schemas.microsoft.com/office/drawing/2014/main" id="{B8F3602C-DEC0-4A1D-935D-971E507F11B9}"/>
+                <a16:creationId xmlns:a16="http://schemas.microsoft.com/office/drawing/2014/main" id="{74C527EC-7E67-4A5F-9588-7F06EFE6BAAA}"/>
               </a:ext>
             </a:extLst>
           </p:cNvPr>
@@ -1241,7 +1241,7 @@
           <p:cNvPr id="3" name="social-title">
             <a:extLst xmlns:a="http://schemas.openxmlformats.org/drawingml/2006/main">
               <a:ext uri="{FF2B5EF4-FFF2-40B4-BE49-F238E27FC236}">
-                <a16:creationId xmlns:a16="http://schemas.microsoft.com/office/drawing/2014/main" id="{EFA0DFEF-7953-42DF-8BC1-CDC73555A7D1}"/>
+                <a16:creationId xmlns:a16="http://schemas.microsoft.com/office/drawing/2014/main" id="{02E7C556-4B99-461A-BCB1-34DC5D00CD2F}"/>
               </a:ext>
             </a:extLst>
           </p:cNvPr>
@@ -1322,7 +1322,7 @@
           <p:cNvPr id="4" name="social-subtitle">
             <a:extLst xmlns:a="http://schemas.openxmlformats.org/drawingml/2006/main">
               <a:ext uri="{FF2B5EF4-FFF2-40B4-BE49-F238E27FC236}">
-                <a16:creationId xmlns:a16="http://schemas.microsoft.com/office/drawing/2014/main" id="{E53887A0-CDD2-498E-B574-0B911367D28C}"/>
+                <a16:creationId xmlns:a16="http://schemas.microsoft.com/office/drawing/2014/main" id="{2108D21C-5E5D-44F1-80A3-6150357A1032}"/>
               </a:ext>
             </a:extLst>
           </p:cNvPr>
@@ -1380,7 +1380,7 @@
           <p:cNvPr id="5" name="social-repo">
             <a:extLst xmlns:a="http://schemas.openxmlformats.org/drawingml/2006/main">
               <a:ext uri="{FF2B5EF4-FFF2-40B4-BE49-F238E27FC236}">
-                <a16:creationId xmlns:a16="http://schemas.microsoft.com/office/drawing/2014/main" id="{BA5D20EF-2AF2-4647-BCAB-A27634856E5E}"/>
+                <a16:creationId xmlns:a16="http://schemas.microsoft.com/office/drawing/2014/main" id="{776E19F5-ED8D-46FB-B7DF-9936B8CCBCA4}"/>
               </a:ext>
             </a:extLst>
           </p:cNvPr>
@@ -1435,10 +1435,10 @@
       </p:sp>
       <p:sp>
         <p:nvSpPr>
-          <p:cNvPr id="6" name="social-flow-field">
-            <a:extLst xmlns:a="http://schemas.openxmlformats.org/drawingml/2006/main">
-              <a:ext uri="{FF2B5EF4-FFF2-40B4-BE49-F238E27FC236}">
-                <a16:creationId xmlns:a16="http://schemas.microsoft.com/office/drawing/2014/main" id="{EEC0AE96-3611-4A09-8CFF-951F04D42AD8}"/>
+          <p:cNvPr id="6" name="social-flow-heading">
+            <a:extLst xmlns:a="http://schemas.openxmlformats.org/drawingml/2006/main">
+              <a:ext uri="{FF2B5EF4-FFF2-40B4-BE49-F238E27FC236}">
+                <a16:creationId xmlns:a16="http://schemas.microsoft.com/office/drawing/2014/main" id="{E7EABD39-C014-4523-BA40-0064256E92AA}"/>
               </a:ext>
             </a:extLst>
           </p:cNvPr>
@@ -1449,27 +1449,85 @@
         </p:nvSpPr>
         <p:spPr>
           <a:xfrm xmlns:a="http://schemas.openxmlformats.org/drawingml/2006/main" rot="0">
-            <a:off x="6210300" y="619125"/>
-            <a:ext cx="4953000" cy="4953000"/>
-          </a:xfrm>
-          <a:prstGeom xmlns:a="http://schemas.openxmlformats.org/drawingml/2006/main" prst="ellipse">
-            <a:avLst/>
-          </a:prstGeom>
-          <a:solidFill xmlns:a="http://schemas.openxmlformats.org/drawingml/2006/main">
-            <a:srgbClr val="E8F3F6"/>
-          </a:solidFill>
+            <a:off x="6705600" y="1076325"/>
+            <a:ext cx="4057650" cy="304800"/>
+          </a:xfrm>
+          <a:prstGeom xmlns:a="http://schemas.openxmlformats.org/drawingml/2006/main" prst="rect">
+            <a:avLst/>
+          </a:prstGeom>
+          <a:noFill xmlns:a="http://schemas.openxmlformats.org/drawingml/2006/main"/>
           <a:ln xmlns:a="http://schemas.openxmlformats.org/drawingml/2006/main" w="0">
             <a:noFill/>
             <a:prstDash val="solid"/>
           </a:ln>
         </p:spPr>
-      </p:sp>
-      <p:sp>
-        <p:nvSpPr>
-          <p:cNvPr id="7" name="social-arrow-1">
-            <a:extLst xmlns:a="http://schemas.openxmlformats.org/drawingml/2006/main">
-              <a:ext uri="{FF2B5EF4-FFF2-40B4-BE49-F238E27FC236}">
-                <a16:creationId xmlns:a16="http://schemas.microsoft.com/office/drawing/2014/main" id="{919FC73F-19CF-4BEB-9CFF-CF62F92EEF43}"/>
+        <p:txBody>
+          <a:bodyPr xmlns:a="http://schemas.openxmlformats.org/drawingml/2006/main" wrap="square" lIns="19050" tIns="9525" rIns="19050" bIns="9525" anchor="ctr">
+            <a:normAutofit fontScale="100000"/>
+          </a:bodyPr>
+          <a:lstStyle xmlns:a="http://schemas.openxmlformats.org/drawingml/2006/main"/>
+          <a:p xmlns:a="http://schemas.openxmlformats.org/drawingml/2006/main">
+            <a:pPr algn="l">
+              <a:defRPr sz="1500" b="1">
+                <a:solidFill>
+                  <a:srgbClr val="26355F"/>
+                </a:solidFill>
+                <a:latin typeface="Arial"/>
+                <a:ea typeface="Arial"/>
+                <a:cs typeface="Arial"/>
+              </a:defRPr>
+            </a:pPr>
+            <a:r>
+              <a:rPr sz="1500" b="1">
+                <a:solidFill>
+                  <a:srgbClr val="26355F"/>
+                </a:solidFill>
+                <a:latin typeface="Arial"/>
+                <a:ea typeface="Arial"/>
+                <a:cs typeface="Arial"/>
+              </a:rPr>
+              <a:t>Selection contract</a:t>
+            </a:r>
+          </a:p>
+        </p:txBody>
+      </p:sp>
+      <p:sp>
+        <p:nvSpPr>
+          <p:cNvPr id="7" name="social-flow-rule">
+            <a:extLst xmlns:a="http://schemas.openxmlformats.org/drawingml/2006/main">
+              <a:ext uri="{FF2B5EF4-FFF2-40B4-BE49-F238E27FC236}">
+                <a16:creationId xmlns:a16="http://schemas.microsoft.com/office/drawing/2014/main" id="{CAC03F8A-6837-491C-AC66-2312B9B75D52}"/>
+              </a:ext>
+            </a:extLst>
+          </p:cNvPr>
+          <p:cNvSpPr>
+            <a:spLocks xmlns:a="http://schemas.openxmlformats.org/drawingml/2006/main" noGrp="1"/>
+          </p:cNvSpPr>
+          <p:nvPr/>
+        </p:nvSpPr>
+        <p:spPr>
+          <a:xfrm xmlns:a="http://schemas.openxmlformats.org/drawingml/2006/main" flipH="0" flipV="0">
+            <a:off x="6705600" y="1457325"/>
+            <a:ext cx="4057650" cy="9525"/>
+          </a:xfrm>
+          <a:prstGeom xmlns:a="http://schemas.openxmlformats.org/drawingml/2006/main" prst="line">
+            <a:avLst/>
+          </a:prstGeom>
+          <a:noFill xmlns:a="http://schemas.openxmlformats.org/drawingml/2006/main"/>
+          <a:ln xmlns:a="http://schemas.openxmlformats.org/drawingml/2006/main" w="11430">
+            <a:solidFill>
+              <a:srgbClr val="CAD3D4"/>
+            </a:solidFill>
+            <a:prstDash val="solid"/>
+          </a:ln>
+        </p:spPr>
+      </p:sp>
+      <p:sp>
+        <p:nvSpPr>
+          <p:cNvPr id="8" name="social-arrow-1">
+            <a:extLst xmlns:a="http://schemas.openxmlformats.org/drawingml/2006/main">
+              <a:ext uri="{FF2B5EF4-FFF2-40B4-BE49-F238E27FC236}">
+                <a16:creationId xmlns:a16="http://schemas.microsoft.com/office/drawing/2014/main" id="{D755BDA2-D49E-41A9-AAE5-229F8BA5B9DF}"/>
               </a:ext>
             </a:extLst>
           </p:cNvPr>
@@ -1480,7 +1538,7 @@
         </p:nvSpPr>
         <p:spPr>
           <a:xfrm xmlns:a="http://schemas.openxmlformats.org/drawingml/2006/main" rot="0">
-            <a:off x="7677150" y="2781300"/>
+            <a:off x="7677150" y="2733675"/>
             <a:ext cx="400050" cy="228600"/>
           </a:xfrm>
           <a:prstGeom xmlns:a="http://schemas.openxmlformats.org/drawingml/2006/main" prst="rightArrow">
@@ -1497,10 +1555,10 @@
       </p:sp>
       <p:sp>
         <p:nvSpPr>
-          <p:cNvPr id="8" name="social-arrow-2">
-            <a:extLst xmlns:a="http://schemas.openxmlformats.org/drawingml/2006/main">
-              <a:ext uri="{FF2B5EF4-FFF2-40B4-BE49-F238E27FC236}">
-                <a16:creationId xmlns:a16="http://schemas.microsoft.com/office/drawing/2014/main" id="{02C8461E-2941-446B-85B8-32C50680AB6E}"/>
+          <p:cNvPr id="9" name="social-arrow-2">
+            <a:extLst xmlns:a="http://schemas.openxmlformats.org/drawingml/2006/main">
+              <a:ext uri="{FF2B5EF4-FFF2-40B4-BE49-F238E27FC236}">
+                <a16:creationId xmlns:a16="http://schemas.microsoft.com/office/drawing/2014/main" id="{40C073FF-FD2B-4C16-A998-8EE1260C7E95}"/>
               </a:ext>
             </a:extLst>
           </p:cNvPr>
@@ -1511,7 +1569,7 @@
         </p:nvSpPr>
         <p:spPr>
           <a:xfrm xmlns:a="http://schemas.openxmlformats.org/drawingml/2006/main" rot="0">
-            <a:off x="9182100" y="2781300"/>
+            <a:off x="9182100" y="2733675"/>
             <a:ext cx="400050" cy="228600"/>
           </a:xfrm>
           <a:prstGeom xmlns:a="http://schemas.openxmlformats.org/drawingml/2006/main" prst="rightArrow">
@@ -1528,10 +1586,10 @@
       </p:sp>
       <p:sp>
         <p:nvSpPr>
-          <p:cNvPr id="9" name="social-candidate-sheet">
-            <a:extLst xmlns:a="http://schemas.openxmlformats.org/drawingml/2006/main">
-              <a:ext uri="{FF2B5EF4-FFF2-40B4-BE49-F238E27FC236}">
-                <a16:creationId xmlns:a16="http://schemas.microsoft.com/office/drawing/2014/main" id="{FE7A12D7-BAEB-4A63-AA28-51A69BB2FFA8}"/>
+          <p:cNvPr id="10" name="social-candidate-sheet">
+            <a:extLst xmlns:a="http://schemas.openxmlformats.org/drawingml/2006/main">
+              <a:ext uri="{FF2B5EF4-FFF2-40B4-BE49-F238E27FC236}">
+                <a16:creationId xmlns:a16="http://schemas.microsoft.com/office/drawing/2014/main" id="{E01EA2B8-292F-4DD5-BFD7-E426B0286EE0}"/>
               </a:ext>
             </a:extLst>
           </p:cNvPr>
@@ -1542,7 +1600,7 @@
         </p:nvSpPr>
         <p:spPr>
           <a:xfrm xmlns:a="http://schemas.openxmlformats.org/drawingml/2006/main" rot="0">
-            <a:off x="6705600" y="2076450"/>
+            <a:off x="6705600" y="2028825"/>
             <a:ext cx="952500" cy="1638300"/>
           </a:xfrm>
           <a:prstGeom xmlns:a="http://schemas.openxmlformats.org/drawingml/2006/main" prst="rect">
@@ -1561,10 +1619,10 @@
       </p:sp>
       <p:sp>
         <p:nvSpPr>
-          <p:cNvPr id="10" name="social-candidate-header">
-            <a:extLst xmlns:a="http://schemas.openxmlformats.org/drawingml/2006/main">
-              <a:ext uri="{FF2B5EF4-FFF2-40B4-BE49-F238E27FC236}">
-                <a16:creationId xmlns:a16="http://schemas.microsoft.com/office/drawing/2014/main" id="{96000AAD-CD0C-400C-ADD8-813B333896EF}"/>
+          <p:cNvPr id="11" name="social-candidate-header">
+            <a:extLst xmlns:a="http://schemas.openxmlformats.org/drawingml/2006/main">
+              <a:ext uri="{FF2B5EF4-FFF2-40B4-BE49-F238E27FC236}">
+                <a16:creationId xmlns:a16="http://schemas.microsoft.com/office/drawing/2014/main" id="{31784001-922A-4135-8BE8-28C159942D22}"/>
               </a:ext>
             </a:extLst>
           </p:cNvPr>
@@ -1575,7 +1633,7 @@
         </p:nvSpPr>
         <p:spPr>
           <a:xfrm xmlns:a="http://schemas.openxmlformats.org/drawingml/2006/main" rot="0">
-            <a:off x="6705600" y="2076450"/>
+            <a:off x="6705600" y="2028825"/>
             <a:ext cx="952500" cy="285750"/>
           </a:xfrm>
           <a:prstGeom xmlns:a="http://schemas.openxmlformats.org/drawingml/2006/main" prst="rect">
@@ -1594,10 +1652,10 @@
       </p:sp>
       <p:sp>
         <p:nvSpPr>
-          <p:cNvPr id="11" name="social-candidate-1">
-            <a:extLst xmlns:a="http://schemas.openxmlformats.org/drawingml/2006/main">
-              <a:ext uri="{FF2B5EF4-FFF2-40B4-BE49-F238E27FC236}">
-                <a16:creationId xmlns:a16="http://schemas.microsoft.com/office/drawing/2014/main" id="{62CD981F-7E43-45BC-8C0F-B1397A6199A1}"/>
+          <p:cNvPr id="12" name="social-candidate-1">
+            <a:extLst xmlns:a="http://schemas.openxmlformats.org/drawingml/2006/main">
+              <a:ext uri="{FF2B5EF4-FFF2-40B4-BE49-F238E27FC236}">
+                <a16:creationId xmlns:a16="http://schemas.microsoft.com/office/drawing/2014/main" id="{B9E28982-FEC4-4C0F-8D26-52C337E92B06}"/>
               </a:ext>
             </a:extLst>
           </p:cNvPr>
@@ -1608,7 +1666,7 @@
         </p:nvSpPr>
         <p:spPr>
           <a:xfrm xmlns:a="http://schemas.openxmlformats.org/drawingml/2006/main" rot="0">
-            <a:off x="6858000" y="2533650"/>
+            <a:off x="6858000" y="2486025"/>
             <a:ext cx="171450" cy="171450"/>
           </a:xfrm>
           <a:prstGeom xmlns:a="http://schemas.openxmlformats.org/drawingml/2006/main" prst="rect">
@@ -1625,10 +1683,10 @@
       </p:sp>
       <p:sp>
         <p:nvSpPr>
-          <p:cNvPr id="12" name="social-candidate-line-1">
-            <a:extLst xmlns:a="http://schemas.openxmlformats.org/drawingml/2006/main">
-              <a:ext uri="{FF2B5EF4-FFF2-40B4-BE49-F238E27FC236}">
-                <a16:creationId xmlns:a16="http://schemas.microsoft.com/office/drawing/2014/main" id="{B92711D1-F86D-4CC7-A5CF-82746124E77D}"/>
+          <p:cNvPr id="13" name="social-candidate-line-1">
+            <a:extLst xmlns:a="http://schemas.openxmlformats.org/drawingml/2006/main">
+              <a:ext uri="{FF2B5EF4-FFF2-40B4-BE49-F238E27FC236}">
+                <a16:creationId xmlns:a16="http://schemas.microsoft.com/office/drawing/2014/main" id="{B3EB3C14-1DE8-4861-806E-C2A7DE84C3F7}"/>
               </a:ext>
             </a:extLst>
           </p:cNvPr>
@@ -1639,7 +1697,7 @@
         </p:nvSpPr>
         <p:spPr>
           <a:xfrm xmlns:a="http://schemas.openxmlformats.org/drawingml/2006/main" flipH="0" flipV="0">
-            <a:off x="7143750" y="2619375"/>
+            <a:off x="7143750" y="2571750"/>
             <a:ext cx="342900" cy="9525"/>
           </a:xfrm>
           <a:prstGeom xmlns:a="http://schemas.openxmlformats.org/drawingml/2006/main" prst="line">
@@ -1656,10 +1714,10 @@
       </p:sp>
       <p:sp>
         <p:nvSpPr>
-          <p:cNvPr id="13" name="social-candidate-2">
-            <a:extLst xmlns:a="http://schemas.openxmlformats.org/drawingml/2006/main">
-              <a:ext uri="{FF2B5EF4-FFF2-40B4-BE49-F238E27FC236}">
-                <a16:creationId xmlns:a16="http://schemas.microsoft.com/office/drawing/2014/main" id="{A1CAB3CD-4FE8-41FD-BD4A-2E0ED642E718}"/>
+          <p:cNvPr id="14" name="social-candidate-2">
+            <a:extLst xmlns:a="http://schemas.openxmlformats.org/drawingml/2006/main">
+              <a:ext uri="{FF2B5EF4-FFF2-40B4-BE49-F238E27FC236}">
+                <a16:creationId xmlns:a16="http://schemas.microsoft.com/office/drawing/2014/main" id="{B532F4E0-D128-4510-A22D-0D13DEEEB7AA}"/>
               </a:ext>
             </a:extLst>
           </p:cNvPr>
@@ -1670,7 +1728,7 @@
         </p:nvSpPr>
         <p:spPr>
           <a:xfrm xmlns:a="http://schemas.openxmlformats.org/drawingml/2006/main" rot="0">
-            <a:off x="6858000" y="2895600"/>
+            <a:off x="6858000" y="2847975"/>
             <a:ext cx="171450" cy="171450"/>
           </a:xfrm>
           <a:prstGeom xmlns:a="http://schemas.openxmlformats.org/drawingml/2006/main" prst="ellipse">
@@ -1689,10 +1747,10 @@
       </p:sp>
       <p:sp>
         <p:nvSpPr>
-          <p:cNvPr id="14" name="social-candidate-line-2">
-            <a:extLst xmlns:a="http://schemas.openxmlformats.org/drawingml/2006/main">
-              <a:ext uri="{FF2B5EF4-FFF2-40B4-BE49-F238E27FC236}">
-                <a16:creationId xmlns:a16="http://schemas.microsoft.com/office/drawing/2014/main" id="{3A3DBD35-4475-4523-864E-570DEF7F0C83}"/>
+          <p:cNvPr id="15" name="social-candidate-line-2">
+            <a:extLst xmlns:a="http://schemas.openxmlformats.org/drawingml/2006/main">
+              <a:ext uri="{FF2B5EF4-FFF2-40B4-BE49-F238E27FC236}">
+                <a16:creationId xmlns:a16="http://schemas.microsoft.com/office/drawing/2014/main" id="{1B8792B6-6F44-45C6-AEE7-5FE14064342F}"/>
               </a:ext>
             </a:extLst>
           </p:cNvPr>
@@ -1703,7 +1761,7 @@
         </p:nvSpPr>
         <p:spPr>
           <a:xfrm xmlns:a="http://schemas.openxmlformats.org/drawingml/2006/main" flipH="0" flipV="0">
-            <a:off x="7143750" y="2981325"/>
+            <a:off x="7143750" y="2933700"/>
             <a:ext cx="342900" cy="9525"/>
           </a:xfrm>
           <a:prstGeom xmlns:a="http://schemas.openxmlformats.org/drawingml/2006/main" prst="line">
@@ -1720,10 +1778,10 @@
       </p:sp>
       <p:sp>
         <p:nvSpPr>
-          <p:cNvPr id="15" name="social-candidate-3">
-            <a:extLst xmlns:a="http://schemas.openxmlformats.org/drawingml/2006/main">
-              <a:ext uri="{FF2B5EF4-FFF2-40B4-BE49-F238E27FC236}">
-                <a16:creationId xmlns:a16="http://schemas.microsoft.com/office/drawing/2014/main" id="{115D9E26-2CA5-4EF2-9627-BC16C93DE546}"/>
+          <p:cNvPr id="16" name="social-candidate-3">
+            <a:extLst xmlns:a="http://schemas.openxmlformats.org/drawingml/2006/main">
+              <a:ext uri="{FF2B5EF4-FFF2-40B4-BE49-F238E27FC236}">
+                <a16:creationId xmlns:a16="http://schemas.microsoft.com/office/drawing/2014/main" id="{ADB89A46-A6EB-429B-B19D-1EAF6BAC1484}"/>
               </a:ext>
             </a:extLst>
           </p:cNvPr>
@@ -1734,7 +1792,7 @@
         </p:nvSpPr>
         <p:spPr>
           <a:xfrm xmlns:a="http://schemas.openxmlformats.org/drawingml/2006/main" rot="0">
-            <a:off x="6858000" y="3257550"/>
+            <a:off x="6858000" y="3209925"/>
             <a:ext cx="171450" cy="171450"/>
           </a:xfrm>
           <a:prstGeom xmlns:a="http://schemas.openxmlformats.org/drawingml/2006/main" prst="diamond">
@@ -1753,10 +1811,10 @@
       </p:sp>
       <p:sp>
         <p:nvSpPr>
-          <p:cNvPr id="16" name="social-candidate-line-3">
-            <a:extLst xmlns:a="http://schemas.openxmlformats.org/drawingml/2006/main">
-              <a:ext uri="{FF2B5EF4-FFF2-40B4-BE49-F238E27FC236}">
-                <a16:creationId xmlns:a16="http://schemas.microsoft.com/office/drawing/2014/main" id="{995DEF46-1890-4FCB-9EE4-7B74B75CB19C}"/>
+          <p:cNvPr id="17" name="social-candidate-line-3">
+            <a:extLst xmlns:a="http://schemas.openxmlformats.org/drawingml/2006/main">
+              <a:ext uri="{FF2B5EF4-FFF2-40B4-BE49-F238E27FC236}">
+                <a16:creationId xmlns:a16="http://schemas.microsoft.com/office/drawing/2014/main" id="{EBAB8413-7E67-45FE-B489-78D13E006126}"/>
               </a:ext>
             </a:extLst>
           </p:cNvPr>
@@ -1767,7 +1825,7 @@
         </p:nvSpPr>
         <p:spPr>
           <a:xfrm xmlns:a="http://schemas.openxmlformats.org/drawingml/2006/main" flipH="0" flipV="0">
-            <a:off x="7143750" y="3343275"/>
+            <a:off x="7143750" y="3295650"/>
             <a:ext cx="342900" cy="9525"/>
           </a:xfrm>
           <a:prstGeom xmlns:a="http://schemas.openxmlformats.org/drawingml/2006/main" prst="line">
@@ -1784,10 +1842,10 @@
       </p:sp>
       <p:sp>
         <p:nvSpPr>
-          <p:cNvPr id="17" name="social-fixed-label">
-            <a:extLst xmlns:a="http://schemas.openxmlformats.org/drawingml/2006/main">
-              <a:ext uri="{FF2B5EF4-FFF2-40B4-BE49-F238E27FC236}">
-                <a16:creationId xmlns:a16="http://schemas.microsoft.com/office/drawing/2014/main" id="{AF64BD90-B14E-4561-9058-50EACE2FAD6D}"/>
+          <p:cNvPr id="18" name="social-fixed-label">
+            <a:extLst xmlns:a="http://schemas.openxmlformats.org/drawingml/2006/main">
+              <a:ext uri="{FF2B5EF4-FFF2-40B4-BE49-F238E27FC236}">
+                <a16:creationId xmlns:a16="http://schemas.microsoft.com/office/drawing/2014/main" id="{CEF54BA7-FC63-406B-A707-A2F149F338AF}"/>
               </a:ext>
             </a:extLst>
           </p:cNvPr>
@@ -1798,7 +1856,7 @@
         </p:nvSpPr>
         <p:spPr>
           <a:xfrm xmlns:a="http://schemas.openxmlformats.org/drawingml/2006/main" rot="0">
-            <a:off x="8143875" y="2305050"/>
+            <a:off x="8143875" y="2257425"/>
             <a:ext cx="981075" cy="228600"/>
           </a:xfrm>
           <a:prstGeom xmlns:a="http://schemas.openxmlformats.org/drawingml/2006/main" prst="rect">
@@ -1842,10 +1900,10 @@
       </p:sp>
       <p:sp>
         <p:nvSpPr>
-          <p:cNvPr id="18" name="social-slot-1">
-            <a:extLst xmlns:a="http://schemas.openxmlformats.org/drawingml/2006/main">
-              <a:ext uri="{FF2B5EF4-FFF2-40B4-BE49-F238E27FC236}">
-                <a16:creationId xmlns:a16="http://schemas.microsoft.com/office/drawing/2014/main" id="{C722F489-8844-4D44-B9FD-D5DB9A0AC8B0}"/>
+          <p:cNvPr id="19" name="social-slot-1">
+            <a:extLst xmlns:a="http://schemas.openxmlformats.org/drawingml/2006/main">
+              <a:ext uri="{FF2B5EF4-FFF2-40B4-BE49-F238E27FC236}">
+                <a16:creationId xmlns:a16="http://schemas.microsoft.com/office/drawing/2014/main" id="{CCFDAD51-F943-447D-AC19-13E1A4EE3442}"/>
               </a:ext>
             </a:extLst>
           </p:cNvPr>
@@ -1856,7 +1914,7 @@
         </p:nvSpPr>
         <p:spPr>
           <a:xfrm xmlns:a="http://schemas.openxmlformats.org/drawingml/2006/main" rot="0">
-            <a:off x="8134350" y="2628900"/>
+            <a:off x="8134350" y="2581275"/>
             <a:ext cx="457200" cy="457200"/>
           </a:xfrm>
           <a:prstGeom xmlns:a="http://schemas.openxmlformats.org/drawingml/2006/main" prst="rect">
@@ -1875,10 +1933,10 @@
       </p:sp>
       <p:sp>
         <p:nvSpPr>
-          <p:cNvPr id="19" name="social-slot-token-1">
-            <a:extLst xmlns:a="http://schemas.openxmlformats.org/drawingml/2006/main">
-              <a:ext uri="{FF2B5EF4-FFF2-40B4-BE49-F238E27FC236}">
-                <a16:creationId xmlns:a16="http://schemas.microsoft.com/office/drawing/2014/main" id="{C000192C-A9D6-4BB8-8274-66ED49EA3005}"/>
+          <p:cNvPr id="20" name="social-slot-token-1">
+            <a:extLst xmlns:a="http://schemas.openxmlformats.org/drawingml/2006/main">
+              <a:ext uri="{FF2B5EF4-FFF2-40B4-BE49-F238E27FC236}">
+                <a16:creationId xmlns:a16="http://schemas.microsoft.com/office/drawing/2014/main" id="{00287579-A3D5-47FB-81E0-7EC79DB2CA4A}"/>
               </a:ext>
             </a:extLst>
           </p:cNvPr>
@@ -1889,7 +1947,7 @@
         </p:nvSpPr>
         <p:spPr>
           <a:xfrm xmlns:a="http://schemas.openxmlformats.org/drawingml/2006/main" rot="0">
-            <a:off x="8267700" y="2762250"/>
+            <a:off x="8267700" y="2714625"/>
             <a:ext cx="190500" cy="190500"/>
           </a:xfrm>
           <a:prstGeom xmlns:a="http://schemas.openxmlformats.org/drawingml/2006/main" prst="ellipse">
@@ -1908,10 +1966,10 @@
       </p:sp>
       <p:sp>
         <p:nvSpPr>
-          <p:cNvPr id="20" name="social-slot-2">
-            <a:extLst xmlns:a="http://schemas.openxmlformats.org/drawingml/2006/main">
-              <a:ext uri="{FF2B5EF4-FFF2-40B4-BE49-F238E27FC236}">
-                <a16:creationId xmlns:a16="http://schemas.microsoft.com/office/drawing/2014/main" id="{8265CF66-4BB6-4DF5-94FB-8351E653AFC3}"/>
+          <p:cNvPr id="21" name="social-slot-2">
+            <a:extLst xmlns:a="http://schemas.openxmlformats.org/drawingml/2006/main">
+              <a:ext uri="{FF2B5EF4-FFF2-40B4-BE49-F238E27FC236}">
+                <a16:creationId xmlns:a16="http://schemas.microsoft.com/office/drawing/2014/main" id="{FBA386A9-AA88-42FF-AC19-AF279719C188}"/>
               </a:ext>
             </a:extLst>
           </p:cNvPr>
@@ -1922,7 +1980,7 @@
         </p:nvSpPr>
         <p:spPr>
           <a:xfrm xmlns:a="http://schemas.openxmlformats.org/drawingml/2006/main" rot="0">
-            <a:off x="8648700" y="2628900"/>
+            <a:off x="8648700" y="2581275"/>
             <a:ext cx="457200" cy="457200"/>
           </a:xfrm>
           <a:prstGeom xmlns:a="http://schemas.openxmlformats.org/drawingml/2006/main" prst="rect">
@@ -1941,10 +1999,10 @@
       </p:sp>
       <p:sp>
         <p:nvSpPr>
-          <p:cNvPr id="21" name="social-slot-token-2">
-            <a:extLst xmlns:a="http://schemas.openxmlformats.org/drawingml/2006/main">
-              <a:ext uri="{FF2B5EF4-FFF2-40B4-BE49-F238E27FC236}">
-                <a16:creationId xmlns:a16="http://schemas.microsoft.com/office/drawing/2014/main" id="{4849BCFF-FC40-4D1E-B9F2-21DA70DDC315}"/>
+          <p:cNvPr id="22" name="social-slot-token-2">
+            <a:extLst xmlns:a="http://schemas.openxmlformats.org/drawingml/2006/main">
+              <a:ext uri="{FF2B5EF4-FFF2-40B4-BE49-F238E27FC236}">
+                <a16:creationId xmlns:a16="http://schemas.microsoft.com/office/drawing/2014/main" id="{1E21DCE3-DEA7-4040-9EA4-259B132E20F9}"/>
               </a:ext>
             </a:extLst>
           </p:cNvPr>
@@ -1955,7 +2013,7 @@
         </p:nvSpPr>
         <p:spPr>
           <a:xfrm xmlns:a="http://schemas.openxmlformats.org/drawingml/2006/main" rot="0">
-            <a:off x="8782050" y="2762250"/>
+            <a:off x="8782050" y="2714625"/>
             <a:ext cx="190500" cy="190500"/>
           </a:xfrm>
           <a:prstGeom xmlns:a="http://schemas.openxmlformats.org/drawingml/2006/main" prst="diamond">
@@ -1974,10 +2032,10 @@
       </p:sp>
       <p:sp>
         <p:nvSpPr>
-          <p:cNvPr id="22" name="social-slot-3">
-            <a:extLst xmlns:a="http://schemas.openxmlformats.org/drawingml/2006/main">
-              <a:ext uri="{FF2B5EF4-FFF2-40B4-BE49-F238E27FC236}">
-                <a16:creationId xmlns:a16="http://schemas.microsoft.com/office/drawing/2014/main" id="{B4A126CC-2744-452A-8792-2356D6DA3D3F}"/>
+          <p:cNvPr id="23" name="social-slot-3">
+            <a:extLst xmlns:a="http://schemas.openxmlformats.org/drawingml/2006/main">
+              <a:ext uri="{FF2B5EF4-FFF2-40B4-BE49-F238E27FC236}">
+                <a16:creationId xmlns:a16="http://schemas.microsoft.com/office/drawing/2014/main" id="{9E10AB4D-7B9F-4065-BFDE-0D421A23044C}"/>
               </a:ext>
             </a:extLst>
           </p:cNvPr>
@@ -1988,7 +2046,7 @@
         </p:nvSpPr>
         <p:spPr>
           <a:xfrm xmlns:a="http://schemas.openxmlformats.org/drawingml/2006/main" rot="0">
-            <a:off x="8134350" y="3143250"/>
+            <a:off x="8134350" y="3095625"/>
             <a:ext cx="457200" cy="457200"/>
           </a:xfrm>
           <a:prstGeom xmlns:a="http://schemas.openxmlformats.org/drawingml/2006/main" prst="rect">
@@ -2007,10 +2065,10 @@
       </p:sp>
       <p:sp>
         <p:nvSpPr>
-          <p:cNvPr id="23" name="social-slot-token-3">
-            <a:extLst xmlns:a="http://schemas.openxmlformats.org/drawingml/2006/main">
-              <a:ext uri="{FF2B5EF4-FFF2-40B4-BE49-F238E27FC236}">
-                <a16:creationId xmlns:a16="http://schemas.microsoft.com/office/drawing/2014/main" id="{01BD54CE-0E1F-47EE-8086-7161E7EB2A90}"/>
+          <p:cNvPr id="24" name="social-slot-token-3">
+            <a:extLst xmlns:a="http://schemas.openxmlformats.org/drawingml/2006/main">
+              <a:ext uri="{FF2B5EF4-FFF2-40B4-BE49-F238E27FC236}">
+                <a16:creationId xmlns:a16="http://schemas.microsoft.com/office/drawing/2014/main" id="{B7DBE308-BDAB-4D10-BC56-90E084D79A16}"/>
               </a:ext>
             </a:extLst>
           </p:cNvPr>
@@ -2021,7 +2079,7 @@
         </p:nvSpPr>
         <p:spPr>
           <a:xfrm xmlns:a="http://schemas.openxmlformats.org/drawingml/2006/main" rot="0">
-            <a:off x="8267700" y="3276600"/>
+            <a:off x="8267700" y="3228975"/>
             <a:ext cx="190500" cy="190500"/>
           </a:xfrm>
           <a:prstGeom xmlns:a="http://schemas.openxmlformats.org/drawingml/2006/main" prst="rect">
@@ -2038,10 +2096,10 @@
       </p:sp>
       <p:sp>
         <p:nvSpPr>
-          <p:cNvPr id="24" name="social-slot-4">
-            <a:extLst xmlns:a="http://schemas.openxmlformats.org/drawingml/2006/main">
-              <a:ext uri="{FF2B5EF4-FFF2-40B4-BE49-F238E27FC236}">
-                <a16:creationId xmlns:a16="http://schemas.microsoft.com/office/drawing/2014/main" id="{6C912248-6996-4C1F-841E-171E2B283354}"/>
+          <p:cNvPr id="25" name="social-slot-4">
+            <a:extLst xmlns:a="http://schemas.openxmlformats.org/drawingml/2006/main">
+              <a:ext uri="{FF2B5EF4-FFF2-40B4-BE49-F238E27FC236}">
+                <a16:creationId xmlns:a16="http://schemas.microsoft.com/office/drawing/2014/main" id="{B3AA2D24-86F1-44C6-AB8A-4170CC1854C4}"/>
               </a:ext>
             </a:extLst>
           </p:cNvPr>
@@ -2052,7 +2110,7 @@
         </p:nvSpPr>
         <p:spPr>
           <a:xfrm xmlns:a="http://schemas.openxmlformats.org/drawingml/2006/main" rot="0">
-            <a:off x="8648700" y="3143250"/>
+            <a:off x="8648700" y="3095625"/>
             <a:ext cx="457200" cy="457200"/>
           </a:xfrm>
           <a:prstGeom xmlns:a="http://schemas.openxmlformats.org/drawingml/2006/main" prst="rect">
@@ -2071,10 +2129,10 @@
       </p:sp>
       <p:sp>
         <p:nvSpPr>
-          <p:cNvPr id="25" name="social-slot-token-4">
-            <a:extLst xmlns:a="http://schemas.openxmlformats.org/drawingml/2006/main">
-              <a:ext uri="{FF2B5EF4-FFF2-40B4-BE49-F238E27FC236}">
-                <a16:creationId xmlns:a16="http://schemas.microsoft.com/office/drawing/2014/main" id="{A045739C-FEEF-4AF4-BFFD-46955C1CA788}"/>
+          <p:cNvPr id="26" name="social-slot-token-4">
+            <a:extLst xmlns:a="http://schemas.openxmlformats.org/drawingml/2006/main">
+              <a:ext uri="{FF2B5EF4-FFF2-40B4-BE49-F238E27FC236}">
+                <a16:creationId xmlns:a16="http://schemas.microsoft.com/office/drawing/2014/main" id="{D1C21513-962B-4E96-949F-0FDDA630CD9E}"/>
               </a:ext>
             </a:extLst>
           </p:cNvPr>
@@ -2085,7 +2143,7 @@
         </p:nvSpPr>
         <p:spPr>
           <a:xfrm xmlns:a="http://schemas.openxmlformats.org/drawingml/2006/main" rot="0">
-            <a:off x="8782050" y="3276600"/>
+            <a:off x="8782050" y="3228975"/>
             <a:ext cx="190500" cy="190500"/>
           </a:xfrm>
           <a:prstGeom xmlns:a="http://schemas.openxmlformats.org/drawingml/2006/main" prst="ellipse">
@@ -2104,10 +2162,10 @@
       </p:sp>
       <p:sp>
         <p:nvSpPr>
-          <p:cNvPr id="26" name="social-ledger">
-            <a:extLst xmlns:a="http://schemas.openxmlformats.org/drawingml/2006/main">
-              <a:ext uri="{FF2B5EF4-FFF2-40B4-BE49-F238E27FC236}">
-                <a16:creationId xmlns:a16="http://schemas.microsoft.com/office/drawing/2014/main" id="{DD5A89D8-A23A-43A8-B39E-9D5015A3BD65}"/>
+          <p:cNvPr id="27" name="social-ledger">
+            <a:extLst xmlns:a="http://schemas.openxmlformats.org/drawingml/2006/main">
+              <a:ext uri="{FF2B5EF4-FFF2-40B4-BE49-F238E27FC236}">
+                <a16:creationId xmlns:a16="http://schemas.microsoft.com/office/drawing/2014/main" id="{83C7D1BE-D38B-4D78-8E99-D17B2FCD163D}"/>
               </a:ext>
             </a:extLst>
           </p:cNvPr>
@@ -2118,7 +2176,7 @@
         </p:nvSpPr>
         <p:spPr>
           <a:xfrm xmlns:a="http://schemas.openxmlformats.org/drawingml/2006/main" rot="0">
-            <a:off x="9601200" y="2076450"/>
+            <a:off x="9601200" y="2028825"/>
             <a:ext cx="1162050" cy="1638300"/>
           </a:xfrm>
           <a:prstGeom xmlns:a="http://schemas.openxmlformats.org/drawingml/2006/main" prst="rect">
@@ -2137,10 +2195,10 @@
       </p:sp>
       <p:sp>
         <p:nvSpPr>
-          <p:cNvPr id="27" name="social-ledger-header">
-            <a:extLst xmlns:a="http://schemas.openxmlformats.org/drawingml/2006/main">
-              <a:ext uri="{FF2B5EF4-FFF2-40B4-BE49-F238E27FC236}">
-                <a16:creationId xmlns:a16="http://schemas.microsoft.com/office/drawing/2014/main" id="{DBBEC000-2E66-4BC2-8782-50B2C7EA0FE1}"/>
+          <p:cNvPr id="28" name="social-ledger-header">
+            <a:extLst xmlns:a="http://schemas.openxmlformats.org/drawingml/2006/main">
+              <a:ext uri="{FF2B5EF4-FFF2-40B4-BE49-F238E27FC236}">
+                <a16:creationId xmlns:a16="http://schemas.microsoft.com/office/drawing/2014/main" id="{C4C97356-3558-4FE6-A3C1-195D03891D10}"/>
               </a:ext>
             </a:extLst>
           </p:cNvPr>
@@ -2151,7 +2209,7 @@
         </p:nvSpPr>
         <p:spPr>
           <a:xfrm xmlns:a="http://schemas.openxmlformats.org/drawingml/2006/main" rot="0">
-            <a:off x="9601200" y="2076450"/>
+            <a:off x="9601200" y="2028825"/>
             <a:ext cx="1162050" cy="285750"/>
           </a:xfrm>
           <a:prstGeom xmlns:a="http://schemas.openxmlformats.org/drawingml/2006/main" prst="rect">
@@ -2170,10 +2228,10 @@
       </p:sp>
       <p:sp>
         <p:nvSpPr>
-          <p:cNvPr id="28" name="social-ledger-check-1-circle">
-            <a:extLst xmlns:a="http://schemas.openxmlformats.org/drawingml/2006/main">
-              <a:ext uri="{FF2B5EF4-FFF2-40B4-BE49-F238E27FC236}">
-                <a16:creationId xmlns:a16="http://schemas.microsoft.com/office/drawing/2014/main" id="{E4A04F40-0662-487B-8682-3911908CB549}"/>
+          <p:cNvPr id="29" name="social-ledger-check-1-circle">
+            <a:extLst xmlns:a="http://schemas.openxmlformats.org/drawingml/2006/main">
+              <a:ext uri="{FF2B5EF4-FFF2-40B4-BE49-F238E27FC236}">
+                <a16:creationId xmlns:a16="http://schemas.microsoft.com/office/drawing/2014/main" id="{1B42B912-A109-4F2B-A0B1-E47F34531B85}"/>
               </a:ext>
             </a:extLst>
           </p:cNvPr>
@@ -2184,7 +2242,7 @@
         </p:nvSpPr>
         <p:spPr>
           <a:xfrm xmlns:a="http://schemas.openxmlformats.org/drawingml/2006/main" rot="0">
-            <a:off x="9753600" y="2533650"/>
+            <a:off x="9753600" y="2486025"/>
             <a:ext cx="190500" cy="190500"/>
           </a:xfrm>
           <a:prstGeom xmlns:a="http://schemas.openxmlformats.org/drawingml/2006/main" prst="ellipse">
@@ -2203,10 +2261,10 @@
       </p:sp>
       <p:sp>
         <p:nvSpPr>
-          <p:cNvPr id="29" name="social-ledger-check-1-left">
-            <a:extLst xmlns:a="http://schemas.openxmlformats.org/drawingml/2006/main">
-              <a:ext uri="{FF2B5EF4-FFF2-40B4-BE49-F238E27FC236}">
-                <a16:creationId xmlns:a16="http://schemas.microsoft.com/office/drawing/2014/main" id="{1F84BCC7-2666-4923-9290-AA40307A84E6}"/>
+          <p:cNvPr id="30" name="social-ledger-check-1-left">
+            <a:extLst xmlns:a="http://schemas.openxmlformats.org/drawingml/2006/main">
+              <a:ext uri="{FF2B5EF4-FFF2-40B4-BE49-F238E27FC236}">
+                <a16:creationId xmlns:a16="http://schemas.microsoft.com/office/drawing/2014/main" id="{2798BCA5-247E-49C8-8E05-81C5635E779D}"/>
               </a:ext>
             </a:extLst>
           </p:cNvPr>
@@ -2217,7 +2275,7 @@
         </p:nvSpPr>
         <p:spPr>
           <a:xfrm xmlns:a="http://schemas.openxmlformats.org/drawingml/2006/main" flipH="0" flipV="0">
-            <a:off x="9801225" y="2628900"/>
+            <a:off x="9801225" y="2581275"/>
             <a:ext cx="38100" cy="38100"/>
           </a:xfrm>
           <a:prstGeom xmlns:a="http://schemas.openxmlformats.org/drawingml/2006/main" prst="line">
@@ -2234,10 +2292,10 @@
       </p:sp>
       <p:sp>
         <p:nvSpPr>
-          <p:cNvPr id="30" name="social-ledger-check-1-right">
-            <a:extLst xmlns:a="http://schemas.openxmlformats.org/drawingml/2006/main">
-              <a:ext uri="{FF2B5EF4-FFF2-40B4-BE49-F238E27FC236}">
-                <a16:creationId xmlns:a16="http://schemas.microsoft.com/office/drawing/2014/main" id="{DD7880A0-FEA5-4BE8-A7CB-2208E31B60B4}"/>
+          <p:cNvPr id="31" name="social-ledger-check-1-right">
+            <a:extLst xmlns:a="http://schemas.openxmlformats.org/drawingml/2006/main">
+              <a:ext uri="{FF2B5EF4-FFF2-40B4-BE49-F238E27FC236}">
+                <a16:creationId xmlns:a16="http://schemas.microsoft.com/office/drawing/2014/main" id="{18FCB082-8C8C-44FC-A484-CB7D0AC06FC0}"/>
               </a:ext>
             </a:extLst>
           </p:cNvPr>
@@ -2248,7 +2306,7 @@
         </p:nvSpPr>
         <p:spPr>
           <a:xfrm xmlns:a="http://schemas.openxmlformats.org/drawingml/2006/main" flipH="0" flipV="1">
-            <a:off x="9839325" y="2590800"/>
+            <a:off x="9839325" y="2543175"/>
             <a:ext cx="66675" cy="76200"/>
           </a:xfrm>
           <a:prstGeom xmlns:a="http://schemas.openxmlformats.org/drawingml/2006/main" prst="line">
@@ -2265,10 +2323,10 @@
       </p:sp>
       <p:sp>
         <p:nvSpPr>
-          <p:cNvPr id="31" name="social-ledger-line-1">
-            <a:extLst xmlns:a="http://schemas.openxmlformats.org/drawingml/2006/main">
-              <a:ext uri="{FF2B5EF4-FFF2-40B4-BE49-F238E27FC236}">
-                <a16:creationId xmlns:a16="http://schemas.microsoft.com/office/drawing/2014/main" id="{2C560161-DE1A-4DFF-9713-726DF402AAF5}"/>
+          <p:cNvPr id="32" name="social-ledger-line-1">
+            <a:extLst xmlns:a="http://schemas.openxmlformats.org/drawingml/2006/main">
+              <a:ext uri="{FF2B5EF4-FFF2-40B4-BE49-F238E27FC236}">
+                <a16:creationId xmlns:a16="http://schemas.microsoft.com/office/drawing/2014/main" id="{1027B84B-607D-481F-9D9C-AE4950D0B5B5}"/>
               </a:ext>
             </a:extLst>
           </p:cNvPr>
@@ -2279,7 +2337,7 @@
         </p:nvSpPr>
         <p:spPr>
           <a:xfrm xmlns:a="http://schemas.openxmlformats.org/drawingml/2006/main" flipH="0" flipV="0">
-            <a:off x="10029825" y="2628900"/>
+            <a:off x="10029825" y="2581275"/>
             <a:ext cx="561975" cy="9525"/>
           </a:xfrm>
           <a:prstGeom xmlns:a="http://schemas.openxmlformats.org/drawingml/2006/main" prst="line">
@@ -2296,10 +2354,10 @@
       </p:sp>
       <p:sp>
         <p:nvSpPr>
-          <p:cNvPr id="32" name="social-ledger-check-2-circle">
-            <a:extLst xmlns:a="http://schemas.openxmlformats.org/drawingml/2006/main">
-              <a:ext uri="{FF2B5EF4-FFF2-40B4-BE49-F238E27FC236}">
-                <a16:creationId xmlns:a16="http://schemas.microsoft.com/office/drawing/2014/main" id="{E66F2C2A-8C55-4BCE-87FA-D0175B4B482C}"/>
+          <p:cNvPr id="33" name="social-ledger-check-2-circle">
+            <a:extLst xmlns:a="http://schemas.openxmlformats.org/drawingml/2006/main">
+              <a:ext uri="{FF2B5EF4-FFF2-40B4-BE49-F238E27FC236}">
+                <a16:creationId xmlns:a16="http://schemas.microsoft.com/office/drawing/2014/main" id="{F642904C-EE35-4C3E-85A2-5B77045C191E}"/>
               </a:ext>
             </a:extLst>
           </p:cNvPr>
@@ -2310,7 +2368,7 @@
         </p:nvSpPr>
         <p:spPr>
           <a:xfrm xmlns:a="http://schemas.openxmlformats.org/drawingml/2006/main" rot="0">
-            <a:off x="9753600" y="2905125"/>
+            <a:off x="9753600" y="2857500"/>
             <a:ext cx="190500" cy="190500"/>
           </a:xfrm>
           <a:prstGeom xmlns:a="http://schemas.openxmlformats.org/drawingml/2006/main" prst="ellipse">
@@ -2329,10 +2387,10 @@
       </p:sp>
       <p:sp>
         <p:nvSpPr>
-          <p:cNvPr id="33" name="social-ledger-check-2-left">
-            <a:extLst xmlns:a="http://schemas.openxmlformats.org/drawingml/2006/main">
-              <a:ext uri="{FF2B5EF4-FFF2-40B4-BE49-F238E27FC236}">
-                <a16:creationId xmlns:a16="http://schemas.microsoft.com/office/drawing/2014/main" id="{94516A00-1D38-4704-8B47-FB1FDC421653}"/>
+          <p:cNvPr id="34" name="social-ledger-check-2-left">
+            <a:extLst xmlns:a="http://schemas.openxmlformats.org/drawingml/2006/main">
+              <a:ext uri="{FF2B5EF4-FFF2-40B4-BE49-F238E27FC236}">
+                <a16:creationId xmlns:a16="http://schemas.microsoft.com/office/drawing/2014/main" id="{A3F3E5B6-27C2-4EAE-B398-D50BB23FCDE4}"/>
               </a:ext>
             </a:extLst>
           </p:cNvPr>
@@ -2343,7 +2401,7 @@
         </p:nvSpPr>
         <p:spPr>
           <a:xfrm xmlns:a="http://schemas.openxmlformats.org/drawingml/2006/main" flipH="0" flipV="0">
-            <a:off x="9801225" y="3000375"/>
+            <a:off x="9801225" y="2952750"/>
             <a:ext cx="38100" cy="38100"/>
           </a:xfrm>
           <a:prstGeom xmlns:a="http://schemas.openxmlformats.org/drawingml/2006/main" prst="line">
@@ -2360,10 +2418,10 @@
       </p:sp>
       <p:sp>
         <p:nvSpPr>
-          <p:cNvPr id="34" name="social-ledger-check-2-right">
-            <a:extLst xmlns:a="http://schemas.openxmlformats.org/drawingml/2006/main">
-              <a:ext uri="{FF2B5EF4-FFF2-40B4-BE49-F238E27FC236}">
-                <a16:creationId xmlns:a16="http://schemas.microsoft.com/office/drawing/2014/main" id="{E8BC427B-D404-49D6-8FD5-D108D5038BD4}"/>
+          <p:cNvPr id="35" name="social-ledger-check-2-right">
+            <a:extLst xmlns:a="http://schemas.openxmlformats.org/drawingml/2006/main">
+              <a:ext uri="{FF2B5EF4-FFF2-40B4-BE49-F238E27FC236}">
+                <a16:creationId xmlns:a16="http://schemas.microsoft.com/office/drawing/2014/main" id="{20363D09-B271-49C0-9D19-38F026E4F46C}"/>
               </a:ext>
             </a:extLst>
           </p:cNvPr>
@@ -2374,7 +2432,7 @@
         </p:nvSpPr>
         <p:spPr>
           <a:xfrm xmlns:a="http://schemas.openxmlformats.org/drawingml/2006/main" flipH="0" flipV="1">
-            <a:off x="9839325" y="2962275"/>
+            <a:off x="9839325" y="2914650"/>
             <a:ext cx="66675" cy="76200"/>
           </a:xfrm>
           <a:prstGeom xmlns:a="http://schemas.openxmlformats.org/drawingml/2006/main" prst="line">
@@ -2391,10 +2449,10 @@
       </p:sp>
       <p:sp>
         <p:nvSpPr>
-          <p:cNvPr id="35" name="social-ledger-line-2">
-            <a:extLst xmlns:a="http://schemas.openxmlformats.org/drawingml/2006/main">
-              <a:ext uri="{FF2B5EF4-FFF2-40B4-BE49-F238E27FC236}">
-                <a16:creationId xmlns:a16="http://schemas.microsoft.com/office/drawing/2014/main" id="{98809413-39DE-4527-A360-E1D819FC6782}"/>
+          <p:cNvPr id="36" name="social-ledger-line-2">
+            <a:extLst xmlns:a="http://schemas.openxmlformats.org/drawingml/2006/main">
+              <a:ext uri="{FF2B5EF4-FFF2-40B4-BE49-F238E27FC236}">
+                <a16:creationId xmlns:a16="http://schemas.microsoft.com/office/drawing/2014/main" id="{5D74AD9A-1FCB-4F9F-A7C7-DDF34EDFDEC7}"/>
               </a:ext>
             </a:extLst>
           </p:cNvPr>
@@ -2405,7 +2463,7 @@
         </p:nvSpPr>
         <p:spPr>
           <a:xfrm xmlns:a="http://schemas.openxmlformats.org/drawingml/2006/main" flipH="0" flipV="0">
-            <a:off x="10029825" y="3000375"/>
+            <a:off x="10029825" y="2952750"/>
             <a:ext cx="561975" cy="9525"/>
           </a:xfrm>
           <a:prstGeom xmlns:a="http://schemas.openxmlformats.org/drawingml/2006/main" prst="line">
@@ -2422,10 +2480,10 @@
       </p:sp>
       <p:sp>
         <p:nvSpPr>
-          <p:cNvPr id="36" name="social-ledger-check-3-circle">
-            <a:extLst xmlns:a="http://schemas.openxmlformats.org/drawingml/2006/main">
-              <a:ext uri="{FF2B5EF4-FFF2-40B4-BE49-F238E27FC236}">
-                <a16:creationId xmlns:a16="http://schemas.microsoft.com/office/drawing/2014/main" id="{22287101-559B-4490-A772-FBFAAA126C17}"/>
+          <p:cNvPr id="37" name="social-ledger-check-3-circle">
+            <a:extLst xmlns:a="http://schemas.openxmlformats.org/drawingml/2006/main">
+              <a:ext uri="{FF2B5EF4-FFF2-40B4-BE49-F238E27FC236}">
+                <a16:creationId xmlns:a16="http://schemas.microsoft.com/office/drawing/2014/main" id="{2607B661-C853-4FDD-A2C5-2C76DB3BE9FA}"/>
               </a:ext>
             </a:extLst>
           </p:cNvPr>
@@ -2436,7 +2494,7 @@
         </p:nvSpPr>
         <p:spPr>
           <a:xfrm xmlns:a="http://schemas.openxmlformats.org/drawingml/2006/main" rot="0">
-            <a:off x="9753600" y="3276600"/>
+            <a:off x="9753600" y="3228975"/>
             <a:ext cx="190500" cy="190500"/>
           </a:xfrm>
           <a:prstGeom xmlns:a="http://schemas.openxmlformats.org/drawingml/2006/main" prst="ellipse">
@@ -2455,10 +2513,10 @@
       </p:sp>
       <p:sp>
         <p:nvSpPr>
-          <p:cNvPr id="37" name="social-ledger-check-3-left">
-            <a:extLst xmlns:a="http://schemas.openxmlformats.org/drawingml/2006/main">
-              <a:ext uri="{FF2B5EF4-FFF2-40B4-BE49-F238E27FC236}">
-                <a16:creationId xmlns:a16="http://schemas.microsoft.com/office/drawing/2014/main" id="{E2946D7A-0618-4319-9FF0-CC413C84B222}"/>
+          <p:cNvPr id="38" name="social-ledger-check-3-left">
+            <a:extLst xmlns:a="http://schemas.openxmlformats.org/drawingml/2006/main">
+              <a:ext uri="{FF2B5EF4-FFF2-40B4-BE49-F238E27FC236}">
+                <a16:creationId xmlns:a16="http://schemas.microsoft.com/office/drawing/2014/main" id="{8C084910-7012-4FA2-9220-FCC021E9348B}"/>
               </a:ext>
             </a:extLst>
           </p:cNvPr>
@@ -2469,7 +2527,7 @@
         </p:nvSpPr>
         <p:spPr>
           <a:xfrm xmlns:a="http://schemas.openxmlformats.org/drawingml/2006/main" flipH="0" flipV="0">
-            <a:off x="9801225" y="3371850"/>
+            <a:off x="9801225" y="3324225"/>
             <a:ext cx="38100" cy="38100"/>
           </a:xfrm>
           <a:prstGeom xmlns:a="http://schemas.openxmlformats.org/drawingml/2006/main" prst="line">
@@ -2486,10 +2544,10 @@
       </p:sp>
       <p:sp>
         <p:nvSpPr>
-          <p:cNvPr id="38" name="social-ledger-check-3-right">
-            <a:extLst xmlns:a="http://schemas.openxmlformats.org/drawingml/2006/main">
-              <a:ext uri="{FF2B5EF4-FFF2-40B4-BE49-F238E27FC236}">
-                <a16:creationId xmlns:a16="http://schemas.microsoft.com/office/drawing/2014/main" id="{55DFD239-97B6-42E7-8FCA-9AC2269C8552}"/>
+          <p:cNvPr id="39" name="social-ledger-check-3-right">
+            <a:extLst xmlns:a="http://schemas.openxmlformats.org/drawingml/2006/main">
+              <a:ext uri="{FF2B5EF4-FFF2-40B4-BE49-F238E27FC236}">
+                <a16:creationId xmlns:a16="http://schemas.microsoft.com/office/drawing/2014/main" id="{3FB2510F-BD4D-44F7-BC66-591A35E2B421}"/>
               </a:ext>
             </a:extLst>
           </p:cNvPr>
@@ -2500,7 +2558,7 @@
         </p:nvSpPr>
         <p:spPr>
           <a:xfrm xmlns:a="http://schemas.openxmlformats.org/drawingml/2006/main" flipH="0" flipV="1">
-            <a:off x="9839325" y="3333750"/>
+            <a:off x="9839325" y="3286125"/>
             <a:ext cx="66675" cy="76200"/>
           </a:xfrm>
           <a:prstGeom xmlns:a="http://schemas.openxmlformats.org/drawingml/2006/main" prst="line">
@@ -2517,10 +2575,10 @@
       </p:sp>
       <p:sp>
         <p:nvSpPr>
-          <p:cNvPr id="39" name="social-ledger-line-3">
-            <a:extLst xmlns:a="http://schemas.openxmlformats.org/drawingml/2006/main">
-              <a:ext uri="{FF2B5EF4-FFF2-40B4-BE49-F238E27FC236}">
-                <a16:creationId xmlns:a16="http://schemas.microsoft.com/office/drawing/2014/main" id="{48BEBDF3-46A3-4AEE-A905-A320359F9C13}"/>
+          <p:cNvPr id="40" name="social-ledger-line-3">
+            <a:extLst xmlns:a="http://schemas.openxmlformats.org/drawingml/2006/main">
+              <a:ext uri="{FF2B5EF4-FFF2-40B4-BE49-F238E27FC236}">
+                <a16:creationId xmlns:a16="http://schemas.microsoft.com/office/drawing/2014/main" id="{AF7A3A84-9AC5-48AF-A8B2-F7558F7519FF}"/>
               </a:ext>
             </a:extLst>
           </p:cNvPr>
@@ -2531,7 +2589,7 @@
         </p:nvSpPr>
         <p:spPr>
           <a:xfrm xmlns:a="http://schemas.openxmlformats.org/drawingml/2006/main" flipH="0" flipV="0">
-            <a:off x="10029825" y="3371850"/>
+            <a:off x="10029825" y="3324225"/>
             <a:ext cx="561975" cy="9525"/>
           </a:xfrm>
           <a:prstGeom xmlns:a="http://schemas.openxmlformats.org/drawingml/2006/main" prst="line">
@@ -2548,10 +2606,10 @@
       </p:sp>
       <p:sp>
         <p:nvSpPr>
-          <p:cNvPr id="40" name="social-candidates-label">
-            <a:extLst xmlns:a="http://schemas.openxmlformats.org/drawingml/2006/main">
-              <a:ext uri="{FF2B5EF4-FFF2-40B4-BE49-F238E27FC236}">
-                <a16:creationId xmlns:a16="http://schemas.microsoft.com/office/drawing/2014/main" id="{CD906E2E-7E9F-438B-A1C3-4E893C70C382}"/>
+          <p:cNvPr id="41" name="social-candidates-label">
+            <a:extLst xmlns:a="http://schemas.openxmlformats.org/drawingml/2006/main">
+              <a:ext uri="{FF2B5EF4-FFF2-40B4-BE49-F238E27FC236}">
+                <a16:creationId xmlns:a16="http://schemas.microsoft.com/office/drawing/2014/main" id="{DCED8E79-E1B0-4AA0-B28C-8BAECFD57949}"/>
               </a:ext>
             </a:extLst>
           </p:cNvPr>
@@ -2562,8 +2620,8 @@
         </p:nvSpPr>
         <p:spPr>
           <a:xfrm xmlns:a="http://schemas.openxmlformats.org/drawingml/2006/main" rot="0">
-            <a:off x="6705600" y="3819525"/>
-            <a:ext cx="952500" cy="238125"/>
+            <a:off x="6705600" y="3790950"/>
+            <a:ext cx="952500" cy="400050"/>
           </a:xfrm>
           <a:prstGeom xmlns:a="http://schemas.openxmlformats.org/drawingml/2006/main" prst="rect">
             <a:avLst/>
@@ -2599,17 +2657,17 @@
                 <a:ea typeface="Arial"/>
                 <a:cs typeface="Arial"/>
               </a:rPr>
-              <a:t>candidates</a:t>
+              <a:t>ranked candidates</a:t>
             </a:r>
           </a:p>
         </p:txBody>
       </p:sp>
       <p:sp>
         <p:nvSpPr>
-          <p:cNvPr id="41" name="social-queue-label">
-            <a:extLst xmlns:a="http://schemas.openxmlformats.org/drawingml/2006/main">
-              <a:ext uri="{FF2B5EF4-FFF2-40B4-BE49-F238E27FC236}">
-                <a16:creationId xmlns:a16="http://schemas.microsoft.com/office/drawing/2014/main" id="{84292661-0E61-4D11-ACEE-175B4DAB2E02}"/>
+          <p:cNvPr id="42" name="social-queue-label">
+            <a:extLst xmlns:a="http://schemas.openxmlformats.org/drawingml/2006/main">
+              <a:ext uri="{FF2B5EF4-FFF2-40B4-BE49-F238E27FC236}">
+                <a16:creationId xmlns:a16="http://schemas.microsoft.com/office/drawing/2014/main" id="{56BA23D2-DB2F-403E-A3F3-FE36AA0313C4}"/>
               </a:ext>
             </a:extLst>
           </p:cNvPr>
@@ -2620,8 +2678,8 @@
         </p:nvSpPr>
         <p:spPr>
           <a:xfrm xmlns:a="http://schemas.openxmlformats.org/drawingml/2006/main" rot="0">
-            <a:off x="8134350" y="3819525"/>
-            <a:ext cx="990600" cy="238125"/>
+            <a:off x="8134350" y="3790950"/>
+            <a:ext cx="990600" cy="400050"/>
           </a:xfrm>
           <a:prstGeom xmlns:a="http://schemas.openxmlformats.org/drawingml/2006/main" prst="rect">
             <a:avLst/>
@@ -2657,17 +2715,17 @@
                 <a:ea typeface="Arial"/>
                 <a:cs typeface="Arial"/>
               </a:rPr>
-              <a:t>queue</a:t>
+              <a:t>fixed queue</a:t>
             </a:r>
           </a:p>
         </p:txBody>
       </p:sp>
       <p:sp>
         <p:nvSpPr>
-          <p:cNvPr id="42" name="social-ledger-label">
-            <a:extLst xmlns:a="http://schemas.openxmlformats.org/drawingml/2006/main">
-              <a:ext uri="{FF2B5EF4-FFF2-40B4-BE49-F238E27FC236}">
-                <a16:creationId xmlns:a16="http://schemas.microsoft.com/office/drawing/2014/main" id="{DC4D170A-493F-429B-88F9-4B058B376386}"/>
+          <p:cNvPr id="43" name="social-ledger-label">
+            <a:extLst xmlns:a="http://schemas.openxmlformats.org/drawingml/2006/main">
+              <a:ext uri="{FF2B5EF4-FFF2-40B4-BE49-F238E27FC236}">
+                <a16:creationId xmlns:a16="http://schemas.microsoft.com/office/drawing/2014/main" id="{A9029247-9690-44D5-A65E-B360BB3C8AC1}"/>
               </a:ext>
             </a:extLst>
           </p:cNvPr>
@@ -2678,8 +2736,8 @@
         </p:nvSpPr>
         <p:spPr>
           <a:xfrm xmlns:a="http://schemas.openxmlformats.org/drawingml/2006/main" rot="0">
-            <a:off x="9601200" y="3819525"/>
-            <a:ext cx="1162050" cy="238125"/>
+            <a:off x="9601200" y="3790950"/>
+            <a:ext cx="1162050" cy="400050"/>
           </a:xfrm>
           <a:prstGeom xmlns:a="http://schemas.openxmlformats.org/drawingml/2006/main" prst="rect">
             <a:avLst/>
@@ -2715,17 +2773,75 @@
                 <a:ea typeface="Arial"/>
                 <a:cs typeface="Arial"/>
               </a:rPr>
-              <a:t>ledger</a:t>
+              <a:t>slot ledger</a:t>
             </a:r>
           </a:p>
         </p:txBody>
       </p:sp>
       <p:sp>
         <p:nvSpPr>
-          <p:cNvPr id="43" name="social-footer-divider">
-            <a:extLst xmlns:a="http://schemas.openxmlformats.org/drawingml/2006/main">
-              <a:ext uri="{FF2B5EF4-FFF2-40B4-BE49-F238E27FC236}">
-                <a16:creationId xmlns:a16="http://schemas.microsoft.com/office/drawing/2014/main" id="{6237EC7D-3DCA-4F46-AA40-A137D6306BAE}"/>
+          <p:cNvPr id="44" name="social-method-line">
+            <a:extLst xmlns:a="http://schemas.openxmlformats.org/drawingml/2006/main">
+              <a:ext uri="{FF2B5EF4-FFF2-40B4-BE49-F238E27FC236}">
+                <a16:creationId xmlns:a16="http://schemas.microsoft.com/office/drawing/2014/main" id="{B9651859-4498-4949-8B24-175ACA38A40E}"/>
+              </a:ext>
+            </a:extLst>
+          </p:cNvPr>
+          <p:cNvSpPr>
+            <a:spLocks xmlns:a="http://schemas.openxmlformats.org/drawingml/2006/main" noGrp="1"/>
+          </p:cNvSpPr>
+          <p:nvPr/>
+        </p:nvSpPr>
+        <p:spPr>
+          <a:xfrm xmlns:a="http://schemas.openxmlformats.org/drawingml/2006/main" rot="0">
+            <a:off x="7458075" y="4495800"/>
+            <a:ext cx="2667000" cy="247650"/>
+          </a:xfrm>
+          <a:prstGeom xmlns:a="http://schemas.openxmlformats.org/drawingml/2006/main" prst="rect">
+            <a:avLst/>
+          </a:prstGeom>
+          <a:noFill xmlns:a="http://schemas.openxmlformats.org/drawingml/2006/main"/>
+          <a:ln xmlns:a="http://schemas.openxmlformats.org/drawingml/2006/main" w="0">
+            <a:noFill/>
+            <a:prstDash val="solid"/>
+          </a:ln>
+        </p:spPr>
+        <p:txBody>
+          <a:bodyPr xmlns:a="http://schemas.openxmlformats.org/drawingml/2006/main" wrap="square" lIns="19050" tIns="9525" rIns="19050" bIns="9525" anchor="ctr">
+            <a:normAutofit fontScale="84178"/>
+          </a:bodyPr>
+          <a:lstStyle xmlns:a="http://schemas.openxmlformats.org/drawingml/2006/main"/>
+          <a:p xmlns:a="http://schemas.openxmlformats.org/drawingml/2006/main">
+            <a:pPr algn="ctr">
+              <a:defRPr sz="1200" b="0">
+                <a:solidFill>
+                  <a:srgbClr val="637077"/>
+                </a:solidFill>
+                <a:latin typeface="Courier New"/>
+                <a:ea typeface="Courier New"/>
+                <a:cs typeface="Courier New"/>
+              </a:defRPr>
+            </a:pPr>
+            <a:r>
+              <a:rPr sz="1200" b="0">
+                <a:solidFill>
+                  <a:srgbClr val="637077"/>
+                </a:solidFill>
+                <a:latin typeface="Courier New"/>
+                <a:ea typeface="Courier New"/>
+                <a:cs typeface="Courier New"/>
+              </a:rPr>
+              <a:t>reserve  -&gt;  deduplicate  -&gt;  fill</a:t>
+            </a:r>
+          </a:p>
+        </p:txBody>
+      </p:sp>
+      <p:sp>
+        <p:nvSpPr>
+          <p:cNvPr id="45" name="social-footer-divider">
+            <a:extLst xmlns:a="http://schemas.openxmlformats.org/drawingml/2006/main">
+              <a:ext uri="{FF2B5EF4-FFF2-40B4-BE49-F238E27FC236}">
+                <a16:creationId xmlns:a16="http://schemas.microsoft.com/office/drawing/2014/main" id="{114E00D1-279C-4A6A-8717-449B05633278}"/>
               </a:ext>
             </a:extLst>
           </p:cNvPr>
@@ -2753,10 +2869,10 @@
       </p:sp>
       <p:sp>
         <p:nvSpPr>
-          <p:cNvPr id="44" name="social-contract-1">
-            <a:extLst xmlns:a="http://schemas.openxmlformats.org/drawingml/2006/main">
-              <a:ext uri="{FF2B5EF4-FFF2-40B4-BE49-F238E27FC236}">
-                <a16:creationId xmlns:a16="http://schemas.microsoft.com/office/drawing/2014/main" id="{5D08E75E-1508-4BB2-BA76-E02E921BDCAF}"/>
+          <p:cNvPr id="46" name="social-contract-line">
+            <a:extLst xmlns:a="http://schemas.openxmlformats.org/drawingml/2006/main">
+              <a:ext uri="{FF2B5EF4-FFF2-40B4-BE49-F238E27FC236}">
+                <a16:creationId xmlns:a16="http://schemas.microsoft.com/office/drawing/2014/main" id="{40540A74-7B5D-4FCB-93A0-29358D9EA183}"/>
               </a:ext>
             </a:extLst>
           </p:cNvPr>
@@ -2768,7 +2884,7 @@
         <p:spPr>
           <a:xfrm xmlns:a="http://schemas.openxmlformats.org/drawingml/2006/main" rot="0">
             <a:off x="666750" y="5124450"/>
-            <a:ext cx="1238250" cy="228600"/>
+            <a:ext cx="5334000" cy="266700"/>
           </a:xfrm>
           <a:prstGeom xmlns:a="http://schemas.openxmlformats.org/drawingml/2006/main" prst="rect">
             <a:avLst/>
@@ -2786,9 +2902,9 @@
           <a:lstStyle xmlns:a="http://schemas.openxmlformats.org/drawingml/2006/main"/>
           <a:p xmlns:a="http://schemas.openxmlformats.org/drawingml/2006/main">
             <a:pPr algn="l">
-              <a:defRPr sz="1050" b="1">
+              <a:defRPr sz="1125" b="0">
                 <a:solidFill>
-                  <a:srgbClr val="26355F"/>
+                  <a:srgbClr val="172027"/>
                 </a:solidFill>
                 <a:latin typeface="Arial"/>
                 <a:ea typeface="Arial"/>
@@ -2796,139 +2912,23 @@
               </a:defRPr>
             </a:pPr>
             <a:r>
-              <a:rPr sz="1050" b="1">
+              <a:rPr sz="1125" b="0">
                 <a:solidFill>
-                  <a:srgbClr val="26355F"/>
+                  <a:srgbClr val="172027"/>
                 </a:solidFill>
                 <a:latin typeface="Arial"/>
                 <a:ea typeface="Arial"/>
                 <a:cs typeface="Arial"/>
               </a:rPr>
-              <a:t>STABLE TIES</a:t>
+              <a:t>Stable ties  |  Fixed capacity  |  Explicit reserves  |  Audit ledger</a:t>
             </a:r>
           </a:p>
         </p:txBody>
       </p:sp>
-      <p:sp>
-        <p:nvSpPr>
-          <p:cNvPr id="45" name="social-contract-2">
-            <a:extLst xmlns:a="http://schemas.openxmlformats.org/drawingml/2006/main">
-              <a:ext uri="{FF2B5EF4-FFF2-40B4-BE49-F238E27FC236}">
-                <a16:creationId xmlns:a16="http://schemas.microsoft.com/office/drawing/2014/main" id="{8B84EB31-FBF0-47E2-971A-B8E045939589}"/>
-              </a:ext>
-            </a:extLst>
-          </p:cNvPr>
-          <p:cNvSpPr>
-            <a:spLocks xmlns:a="http://schemas.openxmlformats.org/drawingml/2006/main" noGrp="1"/>
-          </p:cNvSpPr>
-          <p:nvPr/>
-        </p:nvSpPr>
-        <p:spPr>
-          <a:xfrm xmlns:a="http://schemas.openxmlformats.org/drawingml/2006/main" rot="0">
-            <a:off x="2038350" y="5124450"/>
-            <a:ext cx="1657350" cy="228600"/>
-          </a:xfrm>
-          <a:prstGeom xmlns:a="http://schemas.openxmlformats.org/drawingml/2006/main" prst="rect">
-            <a:avLst/>
-          </a:prstGeom>
-          <a:noFill xmlns:a="http://schemas.openxmlformats.org/drawingml/2006/main"/>
-          <a:ln xmlns:a="http://schemas.openxmlformats.org/drawingml/2006/main" w="0">
-            <a:noFill/>
-            <a:prstDash val="solid"/>
-          </a:ln>
-        </p:spPr>
-        <p:txBody>
-          <a:bodyPr xmlns:a="http://schemas.openxmlformats.org/drawingml/2006/main" wrap="square" lIns="19050" tIns="9525" rIns="19050" bIns="9525" anchor="ctr">
-            <a:normAutofit fontScale="100000"/>
-          </a:bodyPr>
-          <a:lstStyle xmlns:a="http://schemas.openxmlformats.org/drawingml/2006/main"/>
-          <a:p xmlns:a="http://schemas.openxmlformats.org/drawingml/2006/main">
-            <a:pPr algn="l">
-              <a:defRPr sz="1050" b="1">
-                <a:solidFill>
-                  <a:srgbClr val="26785F"/>
-                </a:solidFill>
-                <a:latin typeface="Arial"/>
-                <a:ea typeface="Arial"/>
-                <a:cs typeface="Arial"/>
-              </a:defRPr>
-            </a:pPr>
-            <a:r>
-              <a:rPr sz="1050" b="1">
-                <a:solidFill>
-                  <a:srgbClr val="26785F"/>
-                </a:solidFill>
-                <a:latin typeface="Arial"/>
-                <a:ea typeface="Arial"/>
-                <a:cs typeface="Arial"/>
-              </a:rPr>
-              <a:t>EXPLICIT RESERVES</a:t>
-            </a:r>
-          </a:p>
-        </p:txBody>
-      </p:sp>
-      <p:sp>
-        <p:nvSpPr>
-          <p:cNvPr id="46" name="social-contract-3">
-            <a:extLst xmlns:a="http://schemas.openxmlformats.org/drawingml/2006/main">
-              <a:ext uri="{FF2B5EF4-FFF2-40B4-BE49-F238E27FC236}">
-                <a16:creationId xmlns:a16="http://schemas.microsoft.com/office/drawing/2014/main" id="{1461FE1F-EFD0-42BD-88EF-E8E806F9767B}"/>
-              </a:ext>
-            </a:extLst>
-          </p:cNvPr>
-          <p:cNvSpPr>
-            <a:spLocks xmlns:a="http://schemas.openxmlformats.org/drawingml/2006/main" noGrp="1"/>
-          </p:cNvSpPr>
-          <p:nvPr/>
-        </p:nvSpPr>
-        <p:spPr>
-          <a:xfrm xmlns:a="http://schemas.openxmlformats.org/drawingml/2006/main" rot="0">
-            <a:off x="3829050" y="5124450"/>
-            <a:ext cx="1428750" cy="228600"/>
-          </a:xfrm>
-          <a:prstGeom xmlns:a="http://schemas.openxmlformats.org/drawingml/2006/main" prst="rect">
-            <a:avLst/>
-          </a:prstGeom>
-          <a:noFill xmlns:a="http://schemas.openxmlformats.org/drawingml/2006/main"/>
-          <a:ln xmlns:a="http://schemas.openxmlformats.org/drawingml/2006/main" w="0">
-            <a:noFill/>
-            <a:prstDash val="solid"/>
-          </a:ln>
-        </p:spPr>
-        <p:txBody>
-          <a:bodyPr xmlns:a="http://schemas.openxmlformats.org/drawingml/2006/main" wrap="square" lIns="19050" tIns="9525" rIns="19050" bIns="9525" anchor="ctr">
-            <a:normAutofit fontScale="100000"/>
-          </a:bodyPr>
-          <a:lstStyle xmlns:a="http://schemas.openxmlformats.org/drawingml/2006/main"/>
-          <a:p xmlns:a="http://schemas.openxmlformats.org/drawingml/2006/main">
-            <a:pPr algn="l">
-              <a:defRPr sz="1050" b="1">
-                <a:solidFill>
-                  <a:srgbClr val="765A8D"/>
-                </a:solidFill>
-                <a:latin typeface="Arial"/>
-                <a:ea typeface="Arial"/>
-                <a:cs typeface="Arial"/>
-              </a:defRPr>
-            </a:pPr>
-            <a:r>
-              <a:rPr sz="1050" b="1">
-                <a:solidFill>
-                  <a:srgbClr val="765A8D"/>
-                </a:solidFill>
-                <a:latin typeface="Arial"/>
-                <a:ea typeface="Arial"/>
-                <a:cs typeface="Arial"/>
-              </a:rPr>
-              <a:t>AUDIT LEDGER</a:t>
-            </a:r>
-          </a:p>
-        </p:txBody>
-      </p:sp>
     </p:spTree>
     <p:extLst>
       <p:ext uri="{BB962C8B-B14F-4D97-AF65-F5344CB8AC3E}">
-        <p14:creationId xmlns:p14="http://schemas.microsoft.com/office/powerpoint/2010/main" val="193059961"/>
+        <p14:creationId xmlns:p14="http://schemas.microsoft.com/office/powerpoint/2010/main" val="654893140"/>
       </p:ext>
     </p:extLst>
   </p:cSld>

</xml_diff>

<commit_message>
Normalize artwork typography and API labels
</commit_message>
<xml_diff>
--- a/docs/source/social_preview_editable.pptx
+++ b/docs/source/social_preview_editable.pptx
@@ -2,13 +2,13 @@
 <file path=ppt/presentation.xml><?xml version="1.0" encoding="utf-8"?>
 <p:presentation xmlns:p="http://schemas.openxmlformats.org/presentationml/2006/main">
   <p:sldMasterIdLst>
-    <p:sldMasterId xmlns:r="http://schemas.openxmlformats.org/officeDocument/2006/relationships" id="2147483648" r:id="R6754169e6a1f4450"/>
+    <p:sldMasterId xmlns:r="http://schemas.openxmlformats.org/officeDocument/2006/relationships" id="2147483648" r:id="R4f5559b532164937"/>
   </p:sldMasterIdLst>
   <p:notesMasterIdLst>
-    <p:notesMasterId xmlns:r="http://schemas.openxmlformats.org/officeDocument/2006/relationships" r:id="R1db3c68ecf83447d"/>
+    <p:notesMasterId xmlns:r="http://schemas.openxmlformats.org/officeDocument/2006/relationships" r:id="R0fa257055b5d4d9b"/>
   </p:notesMasterIdLst>
   <p:sldIdLst>
-    <p:sldId xmlns:r="http://schemas.openxmlformats.org/officeDocument/2006/relationships" id="256" r:id="R390bd4febc2a43e5"/>
+    <p:sldId xmlns:r="http://schemas.openxmlformats.org/officeDocument/2006/relationships" id="256" r:id="R3e1f402f57804b13"/>
   </p:sldIdLst>
   <p:sldSz cx="12192000" cy="6096000"/>
   <p:notesSz cx="6858000" cy="9144000"/>
@@ -601,7 +601,7 @@
   </p:cSld>
   <p:clrMap bg1="lt1" tx1="dk1" bg2="lt2" tx2="dk2" accent1="accent1" accent2="accent2" accent3="accent3" accent4="accent4" accent5="accent5" accent6="accent6" hlink="hlink" folHlink="folHlink"/>
   <p:sldLayoutIdLst>
-    <p:sldLayoutId xmlns:r="http://schemas.openxmlformats.org/officeDocument/2006/relationships" id="2147483649" r:id="R0bba223edf8d45ff"/>
+    <p:sldLayoutId xmlns:r="http://schemas.openxmlformats.org/officeDocument/2006/relationships" id="2147483649" r:id="R6fada492e0b548d5"/>
   </p:sldLayoutIdLst>
   <p:txStyles>
     <p:titleStyle>
@@ -1152,7 +1152,7 @@
           <p:cNvPr id="47" name="social-accent-bar">
             <a:extLst xmlns:a="http://schemas.openxmlformats.org/drawingml/2006/main">
               <a:ext uri="{FF2B5EF4-FFF2-40B4-BE49-F238E27FC236}">
-                <a16:creationId xmlns:a16="http://schemas.microsoft.com/office/drawing/2014/main" id="{97382E73-F49D-4DB2-A50D-D6D841A78FA7}"/>
+                <a16:creationId xmlns:a16="http://schemas.microsoft.com/office/drawing/2014/main" id="{92CC152E-B812-43EC-AF45-8E87CAD91870}"/>
               </a:ext>
             </a:extLst>
           </p:cNvPr>
@@ -1183,7 +1183,7 @@
           <p:cNvPr id="2" name="social-eyebrow">
             <a:extLst xmlns:a="http://schemas.openxmlformats.org/drawingml/2006/main">
               <a:ext uri="{FF2B5EF4-FFF2-40B4-BE49-F238E27FC236}">
-                <a16:creationId xmlns:a16="http://schemas.microsoft.com/office/drawing/2014/main" id="{74C527EC-7E67-4A5F-9588-7F06EFE6BAAA}"/>
+                <a16:creationId xmlns:a16="http://schemas.microsoft.com/office/drawing/2014/main" id="{C605CA34-FB72-48D4-82AD-E041745D1B26}"/>
               </a:ext>
             </a:extLst>
           </p:cNvPr>
@@ -1241,7 +1241,7 @@
           <p:cNvPr id="3" name="social-title">
             <a:extLst xmlns:a="http://schemas.openxmlformats.org/drawingml/2006/main">
               <a:ext uri="{FF2B5EF4-FFF2-40B4-BE49-F238E27FC236}">
-                <a16:creationId xmlns:a16="http://schemas.microsoft.com/office/drawing/2014/main" id="{02E7C556-4B99-461A-BCB1-34DC5D00CD2F}"/>
+                <a16:creationId xmlns:a16="http://schemas.microsoft.com/office/drawing/2014/main" id="{73D8DE6C-A67A-4A61-8A91-86B5E37786BB}"/>
               </a:ext>
             </a:extLst>
           </p:cNvPr>
@@ -1322,7 +1322,7 @@
           <p:cNvPr id="4" name="social-subtitle">
             <a:extLst xmlns:a="http://schemas.openxmlformats.org/drawingml/2006/main">
               <a:ext uri="{FF2B5EF4-FFF2-40B4-BE49-F238E27FC236}">
-                <a16:creationId xmlns:a16="http://schemas.microsoft.com/office/drawing/2014/main" id="{2108D21C-5E5D-44F1-80A3-6150357A1032}"/>
+                <a16:creationId xmlns:a16="http://schemas.microsoft.com/office/drawing/2014/main" id="{B07481E4-08D9-4419-B8EC-EB71BB279308}"/>
               </a:ext>
             </a:extLst>
           </p:cNvPr>
@@ -1380,7 +1380,7 @@
           <p:cNvPr id="5" name="social-repo">
             <a:extLst xmlns:a="http://schemas.openxmlformats.org/drawingml/2006/main">
               <a:ext uri="{FF2B5EF4-FFF2-40B4-BE49-F238E27FC236}">
-                <a16:creationId xmlns:a16="http://schemas.microsoft.com/office/drawing/2014/main" id="{776E19F5-ED8D-46FB-B7DF-9936B8CCBCA4}"/>
+                <a16:creationId xmlns:a16="http://schemas.microsoft.com/office/drawing/2014/main" id="{DB3AFCE7-4491-450F-AFFD-72C747A371D7}"/>
               </a:ext>
             </a:extLst>
           </p:cNvPr>
@@ -1438,7 +1438,7 @@
           <p:cNvPr id="6" name="social-flow-heading">
             <a:extLst xmlns:a="http://schemas.openxmlformats.org/drawingml/2006/main">
               <a:ext uri="{FF2B5EF4-FFF2-40B4-BE49-F238E27FC236}">
-                <a16:creationId xmlns:a16="http://schemas.microsoft.com/office/drawing/2014/main" id="{E7EABD39-C014-4523-BA40-0064256E92AA}"/>
+                <a16:creationId xmlns:a16="http://schemas.microsoft.com/office/drawing/2014/main" id="{62F3D1ED-8636-43A0-8D44-5CD6BCE0554C}"/>
               </a:ext>
             </a:extLst>
           </p:cNvPr>
@@ -1496,7 +1496,7 @@
           <p:cNvPr id="7" name="social-flow-rule">
             <a:extLst xmlns:a="http://schemas.openxmlformats.org/drawingml/2006/main">
               <a:ext uri="{FF2B5EF4-FFF2-40B4-BE49-F238E27FC236}">
-                <a16:creationId xmlns:a16="http://schemas.microsoft.com/office/drawing/2014/main" id="{CAC03F8A-6837-491C-AC66-2312B9B75D52}"/>
+                <a16:creationId xmlns:a16="http://schemas.microsoft.com/office/drawing/2014/main" id="{A379C7B1-CFAD-4697-8869-AB5268C57234}"/>
               </a:ext>
             </a:extLst>
           </p:cNvPr>
@@ -1527,7 +1527,7 @@
           <p:cNvPr id="8" name="social-arrow-1">
             <a:extLst xmlns:a="http://schemas.openxmlformats.org/drawingml/2006/main">
               <a:ext uri="{FF2B5EF4-FFF2-40B4-BE49-F238E27FC236}">
-                <a16:creationId xmlns:a16="http://schemas.microsoft.com/office/drawing/2014/main" id="{D755BDA2-D49E-41A9-AAE5-229F8BA5B9DF}"/>
+                <a16:creationId xmlns:a16="http://schemas.microsoft.com/office/drawing/2014/main" id="{F29B1064-708C-47D2-A535-6E719F0CD0A4}"/>
               </a:ext>
             </a:extLst>
           </p:cNvPr>
@@ -1558,7 +1558,7 @@
           <p:cNvPr id="9" name="social-arrow-2">
             <a:extLst xmlns:a="http://schemas.openxmlformats.org/drawingml/2006/main">
               <a:ext uri="{FF2B5EF4-FFF2-40B4-BE49-F238E27FC236}">
-                <a16:creationId xmlns:a16="http://schemas.microsoft.com/office/drawing/2014/main" id="{40C073FF-FD2B-4C16-A998-8EE1260C7E95}"/>
+                <a16:creationId xmlns:a16="http://schemas.microsoft.com/office/drawing/2014/main" id="{E4517AB4-F060-47C3-AD9A-42828653F028}"/>
               </a:ext>
             </a:extLst>
           </p:cNvPr>
@@ -1589,7 +1589,7 @@
           <p:cNvPr id="10" name="social-candidate-sheet">
             <a:extLst xmlns:a="http://schemas.openxmlformats.org/drawingml/2006/main">
               <a:ext uri="{FF2B5EF4-FFF2-40B4-BE49-F238E27FC236}">
-                <a16:creationId xmlns:a16="http://schemas.microsoft.com/office/drawing/2014/main" id="{E01EA2B8-292F-4DD5-BFD7-E426B0286EE0}"/>
+                <a16:creationId xmlns:a16="http://schemas.microsoft.com/office/drawing/2014/main" id="{AFAB7C83-AD17-47AE-8113-125E67A452FF}"/>
               </a:ext>
             </a:extLst>
           </p:cNvPr>
@@ -1622,7 +1622,7 @@
           <p:cNvPr id="11" name="social-candidate-header">
             <a:extLst xmlns:a="http://schemas.openxmlformats.org/drawingml/2006/main">
               <a:ext uri="{FF2B5EF4-FFF2-40B4-BE49-F238E27FC236}">
-                <a16:creationId xmlns:a16="http://schemas.microsoft.com/office/drawing/2014/main" id="{31784001-922A-4135-8BE8-28C159942D22}"/>
+                <a16:creationId xmlns:a16="http://schemas.microsoft.com/office/drawing/2014/main" id="{7EDE2F86-23EC-43D3-B702-2BBCC94192E2}"/>
               </a:ext>
             </a:extLst>
           </p:cNvPr>
@@ -1655,7 +1655,7 @@
           <p:cNvPr id="12" name="social-candidate-1">
             <a:extLst xmlns:a="http://schemas.openxmlformats.org/drawingml/2006/main">
               <a:ext uri="{FF2B5EF4-FFF2-40B4-BE49-F238E27FC236}">
-                <a16:creationId xmlns:a16="http://schemas.microsoft.com/office/drawing/2014/main" id="{B9E28982-FEC4-4C0F-8D26-52C337E92B06}"/>
+                <a16:creationId xmlns:a16="http://schemas.microsoft.com/office/drawing/2014/main" id="{1DBE70C7-2D76-44A6-8E24-AEF5155CD655}"/>
               </a:ext>
             </a:extLst>
           </p:cNvPr>
@@ -1686,7 +1686,7 @@
           <p:cNvPr id="13" name="social-candidate-line-1">
             <a:extLst xmlns:a="http://schemas.openxmlformats.org/drawingml/2006/main">
               <a:ext uri="{FF2B5EF4-FFF2-40B4-BE49-F238E27FC236}">
-                <a16:creationId xmlns:a16="http://schemas.microsoft.com/office/drawing/2014/main" id="{B3EB3C14-1DE8-4861-806E-C2A7DE84C3F7}"/>
+                <a16:creationId xmlns:a16="http://schemas.microsoft.com/office/drawing/2014/main" id="{7851645C-F4DB-47EF-9392-A126F3510652}"/>
               </a:ext>
             </a:extLst>
           </p:cNvPr>
@@ -1717,7 +1717,7 @@
           <p:cNvPr id="14" name="social-candidate-2">
             <a:extLst xmlns:a="http://schemas.openxmlformats.org/drawingml/2006/main">
               <a:ext uri="{FF2B5EF4-FFF2-40B4-BE49-F238E27FC236}">
-                <a16:creationId xmlns:a16="http://schemas.microsoft.com/office/drawing/2014/main" id="{B532F4E0-D128-4510-A22D-0D13DEEEB7AA}"/>
+                <a16:creationId xmlns:a16="http://schemas.microsoft.com/office/drawing/2014/main" id="{8CB0FA18-8128-43BE-83AA-55DF14E6D272}"/>
               </a:ext>
             </a:extLst>
           </p:cNvPr>
@@ -1750,7 +1750,7 @@
           <p:cNvPr id="15" name="social-candidate-line-2">
             <a:extLst xmlns:a="http://schemas.openxmlformats.org/drawingml/2006/main">
               <a:ext uri="{FF2B5EF4-FFF2-40B4-BE49-F238E27FC236}">
-                <a16:creationId xmlns:a16="http://schemas.microsoft.com/office/drawing/2014/main" id="{1B8792B6-6F44-45C6-AEE7-5FE14064342F}"/>
+                <a16:creationId xmlns:a16="http://schemas.microsoft.com/office/drawing/2014/main" id="{5C243D5E-2A3F-4F3A-9B4E-E756EE4096B5}"/>
               </a:ext>
             </a:extLst>
           </p:cNvPr>
@@ -1781,7 +1781,7 @@
           <p:cNvPr id="16" name="social-candidate-3">
             <a:extLst xmlns:a="http://schemas.openxmlformats.org/drawingml/2006/main">
               <a:ext uri="{FF2B5EF4-FFF2-40B4-BE49-F238E27FC236}">
-                <a16:creationId xmlns:a16="http://schemas.microsoft.com/office/drawing/2014/main" id="{ADB89A46-A6EB-429B-B19D-1EAF6BAC1484}"/>
+                <a16:creationId xmlns:a16="http://schemas.microsoft.com/office/drawing/2014/main" id="{0D647C07-66E0-4DB3-84F2-5C3972194A89}"/>
               </a:ext>
             </a:extLst>
           </p:cNvPr>
@@ -1814,7 +1814,7 @@
           <p:cNvPr id="17" name="social-candidate-line-3">
             <a:extLst xmlns:a="http://schemas.openxmlformats.org/drawingml/2006/main">
               <a:ext uri="{FF2B5EF4-FFF2-40B4-BE49-F238E27FC236}">
-                <a16:creationId xmlns:a16="http://schemas.microsoft.com/office/drawing/2014/main" id="{EBAB8413-7E67-45FE-B489-78D13E006126}"/>
+                <a16:creationId xmlns:a16="http://schemas.microsoft.com/office/drawing/2014/main" id="{AE0F7B28-19EF-4A0B-94E5-9ED5650D7378}"/>
               </a:ext>
             </a:extLst>
           </p:cNvPr>
@@ -1845,7 +1845,7 @@
           <p:cNvPr id="18" name="social-fixed-label">
             <a:extLst xmlns:a="http://schemas.openxmlformats.org/drawingml/2006/main">
               <a:ext uri="{FF2B5EF4-FFF2-40B4-BE49-F238E27FC236}">
-                <a16:creationId xmlns:a16="http://schemas.microsoft.com/office/drawing/2014/main" id="{CEF54BA7-FC63-406B-A707-A2F149F338AF}"/>
+                <a16:creationId xmlns:a16="http://schemas.microsoft.com/office/drawing/2014/main" id="{F6D537F0-FD82-4A66-A141-9C1B8021AEDC}"/>
               </a:ext>
             </a:extLst>
           </p:cNvPr>
@@ -1903,7 +1903,7 @@
           <p:cNvPr id="19" name="social-slot-1">
             <a:extLst xmlns:a="http://schemas.openxmlformats.org/drawingml/2006/main">
               <a:ext uri="{FF2B5EF4-FFF2-40B4-BE49-F238E27FC236}">
-                <a16:creationId xmlns:a16="http://schemas.microsoft.com/office/drawing/2014/main" id="{CCFDAD51-F943-447D-AC19-13E1A4EE3442}"/>
+                <a16:creationId xmlns:a16="http://schemas.microsoft.com/office/drawing/2014/main" id="{AD869BF2-F5AF-4A27-8D98-7EC6BBF8A696}"/>
               </a:ext>
             </a:extLst>
           </p:cNvPr>
@@ -1936,7 +1936,7 @@
           <p:cNvPr id="20" name="social-slot-token-1">
             <a:extLst xmlns:a="http://schemas.openxmlformats.org/drawingml/2006/main">
               <a:ext uri="{FF2B5EF4-FFF2-40B4-BE49-F238E27FC236}">
-                <a16:creationId xmlns:a16="http://schemas.microsoft.com/office/drawing/2014/main" id="{00287579-A3D5-47FB-81E0-7EC79DB2CA4A}"/>
+                <a16:creationId xmlns:a16="http://schemas.microsoft.com/office/drawing/2014/main" id="{C4C05C6D-6BD1-4B66-A28A-7DBDF99B613A}"/>
               </a:ext>
             </a:extLst>
           </p:cNvPr>
@@ -1969,7 +1969,7 @@
           <p:cNvPr id="21" name="social-slot-2">
             <a:extLst xmlns:a="http://schemas.openxmlformats.org/drawingml/2006/main">
               <a:ext uri="{FF2B5EF4-FFF2-40B4-BE49-F238E27FC236}">
-                <a16:creationId xmlns:a16="http://schemas.microsoft.com/office/drawing/2014/main" id="{FBA386A9-AA88-42FF-AC19-AF279719C188}"/>
+                <a16:creationId xmlns:a16="http://schemas.microsoft.com/office/drawing/2014/main" id="{D6E48348-32BF-410F-BD07-0311850A47E0}"/>
               </a:ext>
             </a:extLst>
           </p:cNvPr>
@@ -2002,7 +2002,7 @@
           <p:cNvPr id="22" name="social-slot-token-2">
             <a:extLst xmlns:a="http://schemas.openxmlformats.org/drawingml/2006/main">
               <a:ext uri="{FF2B5EF4-FFF2-40B4-BE49-F238E27FC236}">
-                <a16:creationId xmlns:a16="http://schemas.microsoft.com/office/drawing/2014/main" id="{1E21DCE3-DEA7-4040-9EA4-259B132E20F9}"/>
+                <a16:creationId xmlns:a16="http://schemas.microsoft.com/office/drawing/2014/main" id="{E6DE089E-3E91-4CFD-B5E0-0A29F19DD4E0}"/>
               </a:ext>
             </a:extLst>
           </p:cNvPr>
@@ -2035,7 +2035,7 @@
           <p:cNvPr id="23" name="social-slot-3">
             <a:extLst xmlns:a="http://schemas.openxmlformats.org/drawingml/2006/main">
               <a:ext uri="{FF2B5EF4-FFF2-40B4-BE49-F238E27FC236}">
-                <a16:creationId xmlns:a16="http://schemas.microsoft.com/office/drawing/2014/main" id="{9E10AB4D-7B9F-4065-BFDE-0D421A23044C}"/>
+                <a16:creationId xmlns:a16="http://schemas.microsoft.com/office/drawing/2014/main" id="{6B5694D8-1F5C-4F4B-B706-B541E4CE4117}"/>
               </a:ext>
             </a:extLst>
           </p:cNvPr>
@@ -2068,7 +2068,7 @@
           <p:cNvPr id="24" name="social-slot-token-3">
             <a:extLst xmlns:a="http://schemas.openxmlformats.org/drawingml/2006/main">
               <a:ext uri="{FF2B5EF4-FFF2-40B4-BE49-F238E27FC236}">
-                <a16:creationId xmlns:a16="http://schemas.microsoft.com/office/drawing/2014/main" id="{B7DBE308-BDAB-4D10-BC56-90E084D79A16}"/>
+                <a16:creationId xmlns:a16="http://schemas.microsoft.com/office/drawing/2014/main" id="{867F54EC-866E-4046-BB5F-AF60354A9149}"/>
               </a:ext>
             </a:extLst>
           </p:cNvPr>
@@ -2099,7 +2099,7 @@
           <p:cNvPr id="25" name="social-slot-4">
             <a:extLst xmlns:a="http://schemas.openxmlformats.org/drawingml/2006/main">
               <a:ext uri="{FF2B5EF4-FFF2-40B4-BE49-F238E27FC236}">
-                <a16:creationId xmlns:a16="http://schemas.microsoft.com/office/drawing/2014/main" id="{B3AA2D24-86F1-44C6-AB8A-4170CC1854C4}"/>
+                <a16:creationId xmlns:a16="http://schemas.microsoft.com/office/drawing/2014/main" id="{52176730-6D9E-4A9A-BF47-891DB61B0CD3}"/>
               </a:ext>
             </a:extLst>
           </p:cNvPr>
@@ -2132,7 +2132,7 @@
           <p:cNvPr id="26" name="social-slot-token-4">
             <a:extLst xmlns:a="http://schemas.openxmlformats.org/drawingml/2006/main">
               <a:ext uri="{FF2B5EF4-FFF2-40B4-BE49-F238E27FC236}">
-                <a16:creationId xmlns:a16="http://schemas.microsoft.com/office/drawing/2014/main" id="{D1C21513-962B-4E96-949F-0FDDA630CD9E}"/>
+                <a16:creationId xmlns:a16="http://schemas.microsoft.com/office/drawing/2014/main" id="{4DEEC3D9-4F00-4632-8EEC-EBAA64A97543}"/>
               </a:ext>
             </a:extLst>
           </p:cNvPr>
@@ -2165,7 +2165,7 @@
           <p:cNvPr id="27" name="social-ledger">
             <a:extLst xmlns:a="http://schemas.openxmlformats.org/drawingml/2006/main">
               <a:ext uri="{FF2B5EF4-FFF2-40B4-BE49-F238E27FC236}">
-                <a16:creationId xmlns:a16="http://schemas.microsoft.com/office/drawing/2014/main" id="{83C7D1BE-D38B-4D78-8E99-D17B2FCD163D}"/>
+                <a16:creationId xmlns:a16="http://schemas.microsoft.com/office/drawing/2014/main" id="{5A98CAEF-6E14-407D-AD7E-A0A2D23B97AF}"/>
               </a:ext>
             </a:extLst>
           </p:cNvPr>
@@ -2198,7 +2198,7 @@
           <p:cNvPr id="28" name="social-ledger-header">
             <a:extLst xmlns:a="http://schemas.openxmlformats.org/drawingml/2006/main">
               <a:ext uri="{FF2B5EF4-FFF2-40B4-BE49-F238E27FC236}">
-                <a16:creationId xmlns:a16="http://schemas.microsoft.com/office/drawing/2014/main" id="{C4C97356-3558-4FE6-A3C1-195D03891D10}"/>
+                <a16:creationId xmlns:a16="http://schemas.microsoft.com/office/drawing/2014/main" id="{79AAB96F-87BC-422B-B8D8-8318570F8C48}"/>
               </a:ext>
             </a:extLst>
           </p:cNvPr>
@@ -2231,7 +2231,7 @@
           <p:cNvPr id="29" name="social-ledger-check-1-circle">
             <a:extLst xmlns:a="http://schemas.openxmlformats.org/drawingml/2006/main">
               <a:ext uri="{FF2B5EF4-FFF2-40B4-BE49-F238E27FC236}">
-                <a16:creationId xmlns:a16="http://schemas.microsoft.com/office/drawing/2014/main" id="{1B42B912-A109-4F2B-A0B1-E47F34531B85}"/>
+                <a16:creationId xmlns:a16="http://schemas.microsoft.com/office/drawing/2014/main" id="{34508232-7E4F-413D-8808-71D8299571FB}"/>
               </a:ext>
             </a:extLst>
           </p:cNvPr>
@@ -2264,7 +2264,7 @@
           <p:cNvPr id="30" name="social-ledger-check-1-left">
             <a:extLst xmlns:a="http://schemas.openxmlformats.org/drawingml/2006/main">
               <a:ext uri="{FF2B5EF4-FFF2-40B4-BE49-F238E27FC236}">
-                <a16:creationId xmlns:a16="http://schemas.microsoft.com/office/drawing/2014/main" id="{2798BCA5-247E-49C8-8E05-81C5635E779D}"/>
+                <a16:creationId xmlns:a16="http://schemas.microsoft.com/office/drawing/2014/main" id="{6663B54B-E027-4CD6-966B-E8339F8A87C4}"/>
               </a:ext>
             </a:extLst>
           </p:cNvPr>
@@ -2295,7 +2295,7 @@
           <p:cNvPr id="31" name="social-ledger-check-1-right">
             <a:extLst xmlns:a="http://schemas.openxmlformats.org/drawingml/2006/main">
               <a:ext uri="{FF2B5EF4-FFF2-40B4-BE49-F238E27FC236}">
-                <a16:creationId xmlns:a16="http://schemas.microsoft.com/office/drawing/2014/main" id="{18FCB082-8C8C-44FC-A484-CB7D0AC06FC0}"/>
+                <a16:creationId xmlns:a16="http://schemas.microsoft.com/office/drawing/2014/main" id="{4C5FB928-3013-42A3-8529-7F4B0E8E828F}"/>
               </a:ext>
             </a:extLst>
           </p:cNvPr>
@@ -2326,7 +2326,7 @@
           <p:cNvPr id="32" name="social-ledger-line-1">
             <a:extLst xmlns:a="http://schemas.openxmlformats.org/drawingml/2006/main">
               <a:ext uri="{FF2B5EF4-FFF2-40B4-BE49-F238E27FC236}">
-                <a16:creationId xmlns:a16="http://schemas.microsoft.com/office/drawing/2014/main" id="{1027B84B-607D-481F-9D9C-AE4950D0B5B5}"/>
+                <a16:creationId xmlns:a16="http://schemas.microsoft.com/office/drawing/2014/main" id="{A23FCB1C-1FDC-4B53-B789-8691B9D597B8}"/>
               </a:ext>
             </a:extLst>
           </p:cNvPr>
@@ -2357,7 +2357,7 @@
           <p:cNvPr id="33" name="social-ledger-check-2-circle">
             <a:extLst xmlns:a="http://schemas.openxmlformats.org/drawingml/2006/main">
               <a:ext uri="{FF2B5EF4-FFF2-40B4-BE49-F238E27FC236}">
-                <a16:creationId xmlns:a16="http://schemas.microsoft.com/office/drawing/2014/main" id="{F642904C-EE35-4C3E-85A2-5B77045C191E}"/>
+                <a16:creationId xmlns:a16="http://schemas.microsoft.com/office/drawing/2014/main" id="{35006BA7-BF5B-4A4D-A5F7-AB1B750AF5A0}"/>
               </a:ext>
             </a:extLst>
           </p:cNvPr>
@@ -2390,7 +2390,7 @@
           <p:cNvPr id="34" name="social-ledger-check-2-left">
             <a:extLst xmlns:a="http://schemas.openxmlformats.org/drawingml/2006/main">
               <a:ext uri="{FF2B5EF4-FFF2-40B4-BE49-F238E27FC236}">
-                <a16:creationId xmlns:a16="http://schemas.microsoft.com/office/drawing/2014/main" id="{A3F3E5B6-27C2-4EAE-B398-D50BB23FCDE4}"/>
+                <a16:creationId xmlns:a16="http://schemas.microsoft.com/office/drawing/2014/main" id="{6A763CAB-A7D5-4345-BA70-F5BCBE3E6FD1}"/>
               </a:ext>
             </a:extLst>
           </p:cNvPr>
@@ -2421,7 +2421,7 @@
           <p:cNvPr id="35" name="social-ledger-check-2-right">
             <a:extLst xmlns:a="http://schemas.openxmlformats.org/drawingml/2006/main">
               <a:ext uri="{FF2B5EF4-FFF2-40B4-BE49-F238E27FC236}">
-                <a16:creationId xmlns:a16="http://schemas.microsoft.com/office/drawing/2014/main" id="{20363D09-B271-49C0-9D19-38F026E4F46C}"/>
+                <a16:creationId xmlns:a16="http://schemas.microsoft.com/office/drawing/2014/main" id="{676100D9-2F92-400F-AB15-56B099D67C53}"/>
               </a:ext>
             </a:extLst>
           </p:cNvPr>
@@ -2452,7 +2452,7 @@
           <p:cNvPr id="36" name="social-ledger-line-2">
             <a:extLst xmlns:a="http://schemas.openxmlformats.org/drawingml/2006/main">
               <a:ext uri="{FF2B5EF4-FFF2-40B4-BE49-F238E27FC236}">
-                <a16:creationId xmlns:a16="http://schemas.microsoft.com/office/drawing/2014/main" id="{5D74AD9A-1FCB-4F9F-A7C7-DDF34EDFDEC7}"/>
+                <a16:creationId xmlns:a16="http://schemas.microsoft.com/office/drawing/2014/main" id="{7F952E76-CAE0-4443-A394-C5D8FCDAA017}"/>
               </a:ext>
             </a:extLst>
           </p:cNvPr>
@@ -2483,7 +2483,7 @@
           <p:cNvPr id="37" name="social-ledger-check-3-circle">
             <a:extLst xmlns:a="http://schemas.openxmlformats.org/drawingml/2006/main">
               <a:ext uri="{FF2B5EF4-FFF2-40B4-BE49-F238E27FC236}">
-                <a16:creationId xmlns:a16="http://schemas.microsoft.com/office/drawing/2014/main" id="{2607B661-C853-4FDD-A2C5-2C76DB3BE9FA}"/>
+                <a16:creationId xmlns:a16="http://schemas.microsoft.com/office/drawing/2014/main" id="{DB8F5A6F-56C3-45EC-AEBC-3FEA509CE273}"/>
               </a:ext>
             </a:extLst>
           </p:cNvPr>
@@ -2516,7 +2516,7 @@
           <p:cNvPr id="38" name="social-ledger-check-3-left">
             <a:extLst xmlns:a="http://schemas.openxmlformats.org/drawingml/2006/main">
               <a:ext uri="{FF2B5EF4-FFF2-40B4-BE49-F238E27FC236}">
-                <a16:creationId xmlns:a16="http://schemas.microsoft.com/office/drawing/2014/main" id="{8C084910-7012-4FA2-9220-FCC021E9348B}"/>
+                <a16:creationId xmlns:a16="http://schemas.microsoft.com/office/drawing/2014/main" id="{7AFD6C91-4D09-4A75-9755-484F95470901}"/>
               </a:ext>
             </a:extLst>
           </p:cNvPr>
@@ -2547,7 +2547,7 @@
           <p:cNvPr id="39" name="social-ledger-check-3-right">
             <a:extLst xmlns:a="http://schemas.openxmlformats.org/drawingml/2006/main">
               <a:ext uri="{FF2B5EF4-FFF2-40B4-BE49-F238E27FC236}">
-                <a16:creationId xmlns:a16="http://schemas.microsoft.com/office/drawing/2014/main" id="{3FB2510F-BD4D-44F7-BC66-591A35E2B421}"/>
+                <a16:creationId xmlns:a16="http://schemas.microsoft.com/office/drawing/2014/main" id="{A8FFC33F-47CB-4F6D-831D-668610019BF7}"/>
               </a:ext>
             </a:extLst>
           </p:cNvPr>
@@ -2578,7 +2578,7 @@
           <p:cNvPr id="40" name="social-ledger-line-3">
             <a:extLst xmlns:a="http://schemas.openxmlformats.org/drawingml/2006/main">
               <a:ext uri="{FF2B5EF4-FFF2-40B4-BE49-F238E27FC236}">
-                <a16:creationId xmlns:a16="http://schemas.microsoft.com/office/drawing/2014/main" id="{AF7A3A84-9AC5-48AF-A8B2-F7558F7519FF}"/>
+                <a16:creationId xmlns:a16="http://schemas.microsoft.com/office/drawing/2014/main" id="{CBC1DF36-3EEB-4E13-AD90-4266B4622C47}"/>
               </a:ext>
             </a:extLst>
           </p:cNvPr>
@@ -2609,7 +2609,7 @@
           <p:cNvPr id="41" name="social-candidates-label">
             <a:extLst xmlns:a="http://schemas.openxmlformats.org/drawingml/2006/main">
               <a:ext uri="{FF2B5EF4-FFF2-40B4-BE49-F238E27FC236}">
-                <a16:creationId xmlns:a16="http://schemas.microsoft.com/office/drawing/2014/main" id="{DCED8E79-E1B0-4AA0-B28C-8BAECFD57949}"/>
+                <a16:creationId xmlns:a16="http://schemas.microsoft.com/office/drawing/2014/main" id="{910AF37F-D96D-40C6-8777-0A70D3B19C7D}"/>
               </a:ext>
             </a:extLst>
           </p:cNvPr>
@@ -2667,7 +2667,7 @@
           <p:cNvPr id="42" name="social-queue-label">
             <a:extLst xmlns:a="http://schemas.openxmlformats.org/drawingml/2006/main">
               <a:ext uri="{FF2B5EF4-FFF2-40B4-BE49-F238E27FC236}">
-                <a16:creationId xmlns:a16="http://schemas.microsoft.com/office/drawing/2014/main" id="{56BA23D2-DB2F-403E-A3F3-FE36AA0313C4}"/>
+                <a16:creationId xmlns:a16="http://schemas.microsoft.com/office/drawing/2014/main" id="{4716C71A-8218-469C-82C6-A57A2D1AD467}"/>
               </a:ext>
             </a:extLst>
           </p:cNvPr>
@@ -2725,7 +2725,7 @@
           <p:cNvPr id="43" name="social-ledger-label">
             <a:extLst xmlns:a="http://schemas.openxmlformats.org/drawingml/2006/main">
               <a:ext uri="{FF2B5EF4-FFF2-40B4-BE49-F238E27FC236}">
-                <a16:creationId xmlns:a16="http://schemas.microsoft.com/office/drawing/2014/main" id="{A9029247-9690-44D5-A65E-B360BB3C8AC1}"/>
+                <a16:creationId xmlns:a16="http://schemas.microsoft.com/office/drawing/2014/main" id="{279690F5-585F-4D5C-B256-78BAAFAB96CD}"/>
               </a:ext>
             </a:extLst>
           </p:cNvPr>
@@ -2783,7 +2783,7 @@
           <p:cNvPr id="44" name="social-method-line">
             <a:extLst xmlns:a="http://schemas.openxmlformats.org/drawingml/2006/main">
               <a:ext uri="{FF2B5EF4-FFF2-40B4-BE49-F238E27FC236}">
-                <a16:creationId xmlns:a16="http://schemas.microsoft.com/office/drawing/2014/main" id="{B9651859-4498-4949-8B24-175ACA38A40E}"/>
+                <a16:creationId xmlns:a16="http://schemas.microsoft.com/office/drawing/2014/main" id="{D6677806-C6A4-406D-BEEF-50B6B42CD9C1}"/>
               </a:ext>
             </a:extLst>
           </p:cNvPr>
@@ -2808,7 +2808,7 @@
         </p:spPr>
         <p:txBody>
           <a:bodyPr xmlns:a="http://schemas.openxmlformats.org/drawingml/2006/main" wrap="square" lIns="19050" tIns="9525" rIns="19050" bIns="9525" anchor="ctr">
-            <a:normAutofit fontScale="84178"/>
+            <a:normAutofit fontScale="96259"/>
           </a:bodyPr>
           <a:lstStyle xmlns:a="http://schemas.openxmlformats.org/drawingml/2006/main"/>
           <a:p xmlns:a="http://schemas.openxmlformats.org/drawingml/2006/main">
@@ -2831,7 +2831,7 @@
                 <a:ea typeface="Courier New"/>
                 <a:cs typeface="Courier New"/>
               </a:rPr>
-              <a:t>reserve  -&gt;  deduplicate  -&gt;  fill</a:t>
+              <a:t>reserve -&gt; deduplicate -&gt; fill</a:t>
             </a:r>
           </a:p>
         </p:txBody>
@@ -2841,7 +2841,7 @@
           <p:cNvPr id="45" name="social-footer-divider">
             <a:extLst xmlns:a="http://schemas.openxmlformats.org/drawingml/2006/main">
               <a:ext uri="{FF2B5EF4-FFF2-40B4-BE49-F238E27FC236}">
-                <a16:creationId xmlns:a16="http://schemas.microsoft.com/office/drawing/2014/main" id="{114E00D1-279C-4A6A-8717-449B05633278}"/>
+                <a16:creationId xmlns:a16="http://schemas.microsoft.com/office/drawing/2014/main" id="{60929B51-16D2-40F8-89EE-A85275317F1C}"/>
               </a:ext>
             </a:extLst>
           </p:cNvPr>
@@ -2872,7 +2872,7 @@
           <p:cNvPr id="46" name="social-contract-line">
             <a:extLst xmlns:a="http://schemas.openxmlformats.org/drawingml/2006/main">
               <a:ext uri="{FF2B5EF4-FFF2-40B4-BE49-F238E27FC236}">
-                <a16:creationId xmlns:a16="http://schemas.microsoft.com/office/drawing/2014/main" id="{40540A74-7B5D-4FCB-93A0-29358D9EA183}"/>
+                <a16:creationId xmlns:a16="http://schemas.microsoft.com/office/drawing/2014/main" id="{922982C3-1D5E-444A-82E3-DADF185ECB76}"/>
               </a:ext>
             </a:extLst>
           </p:cNvPr>
@@ -2928,7 +2928,7 @@
     </p:spTree>
     <p:extLst>
       <p:ext uri="{BB962C8B-B14F-4D97-AF65-F5344CB8AC3E}">
-        <p14:creationId xmlns:p14="http://schemas.microsoft.com/office/powerpoint/2010/main" val="654893140"/>
+        <p14:creationId xmlns:p14="http://schemas.microsoft.com/office/powerpoint/2010/main" val="1542065122"/>
       </p:ext>
     </p:extLst>
   </p:cSld>

</xml_diff>

<commit_message>
Polish artwork alignment and naming
</commit_message>
<xml_diff>
--- a/docs/source/social_preview_editable.pptx
+++ b/docs/source/social_preview_editable.pptx
@@ -2,13 +2,13 @@
 <file path=ppt/presentation.xml><?xml version="1.0" encoding="utf-8"?>
 <p:presentation xmlns:p="http://schemas.openxmlformats.org/presentationml/2006/main">
   <p:sldMasterIdLst>
-    <p:sldMasterId xmlns:r="http://schemas.openxmlformats.org/officeDocument/2006/relationships" id="2147483648" r:id="R4f5559b532164937"/>
+    <p:sldMasterId xmlns:r="http://schemas.openxmlformats.org/officeDocument/2006/relationships" id="2147483648" r:id="R8f42bb70c5ab4782"/>
   </p:sldMasterIdLst>
   <p:notesMasterIdLst>
-    <p:notesMasterId xmlns:r="http://schemas.openxmlformats.org/officeDocument/2006/relationships" r:id="R0fa257055b5d4d9b"/>
+    <p:notesMasterId xmlns:r="http://schemas.openxmlformats.org/officeDocument/2006/relationships" r:id="R5eef95455b1643a6"/>
   </p:notesMasterIdLst>
   <p:sldIdLst>
-    <p:sldId xmlns:r="http://schemas.openxmlformats.org/officeDocument/2006/relationships" id="256" r:id="R3e1f402f57804b13"/>
+    <p:sldId xmlns:r="http://schemas.openxmlformats.org/officeDocument/2006/relationships" id="256" r:id="R12d7fd496849431e"/>
   </p:sldIdLst>
   <p:sldSz cx="12192000" cy="6096000"/>
   <p:notesSz cx="6858000" cy="9144000"/>
@@ -601,7 +601,7 @@
   </p:cSld>
   <p:clrMap bg1="lt1" tx1="dk1" bg2="lt2" tx2="dk2" accent1="accent1" accent2="accent2" accent3="accent3" accent4="accent4" accent5="accent5" accent6="accent6" hlink="hlink" folHlink="folHlink"/>
   <p:sldLayoutIdLst>
-    <p:sldLayoutId xmlns:r="http://schemas.openxmlformats.org/officeDocument/2006/relationships" id="2147483649" r:id="R6fada492e0b548d5"/>
+    <p:sldLayoutId xmlns:r="http://schemas.openxmlformats.org/officeDocument/2006/relationships" id="2147483649" r:id="Rbd3834bf0bd0450e"/>
   </p:sldLayoutIdLst>
   <p:txStyles>
     <p:titleStyle>
@@ -1149,10 +1149,10 @@
       </p:grpSpPr>
       <p:sp>
         <p:nvSpPr>
-          <p:cNvPr id="47" name="social-accent-bar">
-            <a:extLst xmlns:a="http://schemas.openxmlformats.org/drawingml/2006/main">
-              <a:ext uri="{FF2B5EF4-FFF2-40B4-BE49-F238E27FC236}">
-                <a16:creationId xmlns:a16="http://schemas.microsoft.com/office/drawing/2014/main" id="{92CC152E-B812-43EC-AF45-8E87CAD91870}"/>
+          <p:cNvPr id="46" name="social-accent-bar">
+            <a:extLst xmlns:a="http://schemas.openxmlformats.org/drawingml/2006/main">
+              <a:ext uri="{FF2B5EF4-FFF2-40B4-BE49-F238E27FC236}">
+                <a16:creationId xmlns:a16="http://schemas.microsoft.com/office/drawing/2014/main" id="{86D35157-2C3B-42F8-AF1C-5879CFD9AB2E}"/>
               </a:ext>
             </a:extLst>
           </p:cNvPr>
@@ -1180,10 +1180,10 @@
       </p:sp>
       <p:sp>
         <p:nvSpPr>
-          <p:cNvPr id="2" name="social-eyebrow">
-            <a:extLst xmlns:a="http://schemas.openxmlformats.org/drawingml/2006/main">
-              <a:ext uri="{FF2B5EF4-FFF2-40B4-BE49-F238E27FC236}">
-                <a16:creationId xmlns:a16="http://schemas.microsoft.com/office/drawing/2014/main" id="{C605CA34-FB72-48D4-82AD-E041745D1B26}"/>
+          <p:cNvPr id="2" name="social-title">
+            <a:extLst xmlns:a="http://schemas.openxmlformats.org/drawingml/2006/main">
+              <a:ext uri="{FF2B5EF4-FFF2-40B4-BE49-F238E27FC236}">
+                <a16:creationId xmlns:a16="http://schemas.microsoft.com/office/drawing/2014/main" id="{E2798445-AE17-4C5F-B04E-BCAAE37D1927}"/>
               </a:ext>
             </a:extLst>
           </p:cNvPr>
@@ -1194,65 +1194,7 @@
         </p:nvSpPr>
         <p:spPr>
           <a:xfrm xmlns:a="http://schemas.openxmlformats.org/drawingml/2006/main" rot="0">
-            <a:off x="666750" y="552450"/>
-            <a:ext cx="4095750" cy="266700"/>
-          </a:xfrm>
-          <a:prstGeom xmlns:a="http://schemas.openxmlformats.org/drawingml/2006/main" prst="rect">
-            <a:avLst/>
-          </a:prstGeom>
-          <a:noFill xmlns:a="http://schemas.openxmlformats.org/drawingml/2006/main"/>
-          <a:ln xmlns:a="http://schemas.openxmlformats.org/drawingml/2006/main" w="0">
-            <a:noFill/>
-            <a:prstDash val="solid"/>
-          </a:ln>
-        </p:spPr>
-        <p:txBody>
-          <a:bodyPr xmlns:a="http://schemas.openxmlformats.org/drawingml/2006/main" wrap="square" lIns="19050" tIns="9525" rIns="19050" bIns="9525" anchor="ctr">
-            <a:normAutofit fontScale="100000"/>
-          </a:bodyPr>
-          <a:lstStyle xmlns:a="http://schemas.openxmlformats.org/drawingml/2006/main"/>
-          <a:p xmlns:a="http://schemas.openxmlformats.org/drawingml/2006/main">
-            <a:pPr algn="l">
-              <a:defRPr sz="1125" b="1">
-                <a:solidFill>
-                  <a:srgbClr val="26785F"/>
-                </a:solidFill>
-                <a:latin typeface="Arial"/>
-                <a:ea typeface="Arial"/>
-                <a:cs typeface="Arial"/>
-              </a:defRPr>
-            </a:pPr>
-            <a:r>
-              <a:rPr sz="1125" b="1">
-                <a:solidFill>
-                  <a:srgbClr val="26785F"/>
-                </a:solidFill>
-                <a:latin typeface="Arial"/>
-                <a:ea typeface="Arial"/>
-                <a:cs typeface="Arial"/>
-              </a:rPr>
-              <a:t>OPEN REFERENCE IMPLEMENTATION</a:t>
-            </a:r>
-          </a:p>
-        </p:txBody>
-      </p:sp>
-      <p:sp>
-        <p:nvSpPr>
-          <p:cNvPr id="3" name="social-title">
-            <a:extLst xmlns:a="http://schemas.openxmlformats.org/drawingml/2006/main">
-              <a:ext uri="{FF2B5EF4-FFF2-40B4-BE49-F238E27FC236}">
-                <a16:creationId xmlns:a16="http://schemas.microsoft.com/office/drawing/2014/main" id="{73D8DE6C-A67A-4A61-8A91-86B5E37786BB}"/>
-              </a:ext>
-            </a:extLst>
-          </p:cNvPr>
-          <p:cNvSpPr>
-            <a:spLocks xmlns:a="http://schemas.openxmlformats.org/drawingml/2006/main" noGrp="1"/>
-          </p:cNvSpPr>
-          <p:nvPr/>
-        </p:nvSpPr>
-        <p:spPr>
-          <a:xfrm xmlns:a="http://schemas.openxmlformats.org/drawingml/2006/main" rot="0">
-            <a:off x="666750" y="1085850"/>
+            <a:off x="666750" y="666750"/>
             <a:ext cx="5143500" cy="1409700"/>
           </a:xfrm>
           <a:prstGeom xmlns:a="http://schemas.openxmlformats.org/drawingml/2006/main" prst="rect">
@@ -1319,10 +1261,10 @@
       </p:sp>
       <p:sp>
         <p:nvSpPr>
-          <p:cNvPr id="4" name="social-subtitle">
-            <a:extLst xmlns:a="http://schemas.openxmlformats.org/drawingml/2006/main">
-              <a:ext uri="{FF2B5EF4-FFF2-40B4-BE49-F238E27FC236}">
-                <a16:creationId xmlns:a16="http://schemas.microsoft.com/office/drawing/2014/main" id="{B07481E4-08D9-4419-B8EC-EB71BB279308}"/>
+          <p:cNvPr id="3" name="social-subtitle">
+            <a:extLst xmlns:a="http://schemas.openxmlformats.org/drawingml/2006/main">
+              <a:ext uri="{FF2B5EF4-FFF2-40B4-BE49-F238E27FC236}">
+                <a16:creationId xmlns:a16="http://schemas.microsoft.com/office/drawing/2014/main" id="{E48DB24E-B72B-4358-B7CE-C8953E066382}"/>
               </a:ext>
             </a:extLst>
           </p:cNvPr>
@@ -1333,7 +1275,7 @@
         </p:nvSpPr>
         <p:spPr>
           <a:xfrm xmlns:a="http://schemas.openxmlformats.org/drawingml/2006/main" rot="0">
-            <a:off x="666750" y="2724150"/>
+            <a:off x="666750" y="2381250"/>
             <a:ext cx="4953000" cy="781050"/>
           </a:xfrm>
           <a:prstGeom xmlns:a="http://schemas.openxmlformats.org/drawingml/2006/main" prst="rect">
@@ -1377,10 +1319,10 @@
       </p:sp>
       <p:sp>
         <p:nvSpPr>
-          <p:cNvPr id="5" name="social-repo">
-            <a:extLst xmlns:a="http://schemas.openxmlformats.org/drawingml/2006/main">
-              <a:ext uri="{FF2B5EF4-FFF2-40B4-BE49-F238E27FC236}">
-                <a16:creationId xmlns:a16="http://schemas.microsoft.com/office/drawing/2014/main" id="{DB3AFCE7-4491-450F-AFFD-72C747A371D7}"/>
+          <p:cNvPr id="4" name="social-repo">
+            <a:extLst xmlns:a="http://schemas.openxmlformats.org/drawingml/2006/main">
+              <a:ext uri="{FF2B5EF4-FFF2-40B4-BE49-F238E27FC236}">
+                <a16:creationId xmlns:a16="http://schemas.microsoft.com/office/drawing/2014/main" id="{0D51DA64-E05B-4DA2-90CA-6CCA976C1F70}"/>
               </a:ext>
             </a:extLst>
           </p:cNvPr>
@@ -1391,7 +1333,7 @@
         </p:nvSpPr>
         <p:spPr>
           <a:xfrm xmlns:a="http://schemas.openxmlformats.org/drawingml/2006/main" rot="0">
-            <a:off x="666750" y="3943350"/>
+            <a:off x="666750" y="3524250"/>
             <a:ext cx="4953000" cy="285750"/>
           </a:xfrm>
           <a:prstGeom xmlns:a="http://schemas.openxmlformats.org/drawingml/2006/main" prst="rect">
@@ -1414,9 +1356,9 @@
                 <a:solidFill>
                   <a:srgbClr val="26355F"/>
                 </a:solidFill>
-                <a:latin typeface="Courier New"/>
-                <a:ea typeface="Courier New"/>
-                <a:cs typeface="Courier New"/>
+                <a:latin typeface="Arial"/>
+                <a:ea typeface="Arial"/>
+                <a:cs typeface="Arial"/>
               </a:defRPr>
             </a:pPr>
             <a:r>
@@ -1424,9 +1366,9 @@
                 <a:solidFill>
                   <a:srgbClr val="26355F"/>
                 </a:solidFill>
-                <a:latin typeface="Courier New"/>
-                <a:ea typeface="Courier New"/>
-                <a:cs typeface="Courier New"/>
+                <a:latin typeface="Arial"/>
+                <a:ea typeface="Arial"/>
+                <a:cs typeface="Arial"/>
               </a:rPr>
               <a:t>github.com/SiqiLi77/governed-wastewater-review-queues</a:t>
             </a:r>
@@ -1435,10 +1377,10 @@
       </p:sp>
       <p:sp>
         <p:nvSpPr>
-          <p:cNvPr id="6" name="social-flow-heading">
-            <a:extLst xmlns:a="http://schemas.openxmlformats.org/drawingml/2006/main">
-              <a:ext uri="{FF2B5EF4-FFF2-40B4-BE49-F238E27FC236}">
-                <a16:creationId xmlns:a16="http://schemas.microsoft.com/office/drawing/2014/main" id="{62F3D1ED-8636-43A0-8D44-5CD6BCE0554C}"/>
+          <p:cNvPr id="5" name="social-flow-heading">
+            <a:extLst xmlns:a="http://schemas.openxmlformats.org/drawingml/2006/main">
+              <a:ext uri="{FF2B5EF4-FFF2-40B4-BE49-F238E27FC236}">
+                <a16:creationId xmlns:a16="http://schemas.microsoft.com/office/drawing/2014/main" id="{56786FC8-21D1-4925-9CA6-41F55DB3595E}"/>
               </a:ext>
             </a:extLst>
           </p:cNvPr>
@@ -1449,7 +1391,7 @@
         </p:nvSpPr>
         <p:spPr>
           <a:xfrm xmlns:a="http://schemas.openxmlformats.org/drawingml/2006/main" rot="0">
-            <a:off x="6705600" y="1076325"/>
+            <a:off x="6705600" y="762000"/>
             <a:ext cx="4057650" cy="304800"/>
           </a:xfrm>
           <a:prstGeom xmlns:a="http://schemas.openxmlformats.org/drawingml/2006/main" prst="rect">
@@ -1467,7 +1409,7 @@
           </a:bodyPr>
           <a:lstStyle xmlns:a="http://schemas.openxmlformats.org/drawingml/2006/main"/>
           <a:p xmlns:a="http://schemas.openxmlformats.org/drawingml/2006/main">
-            <a:pPr algn="l">
+            <a:pPr algn="ctr">
               <a:defRPr sz="1500" b="1">
                 <a:solidFill>
                   <a:srgbClr val="26355F"/>
@@ -1493,10 +1435,10 @@
       </p:sp>
       <p:sp>
         <p:nvSpPr>
-          <p:cNvPr id="7" name="social-flow-rule">
-            <a:extLst xmlns:a="http://schemas.openxmlformats.org/drawingml/2006/main">
-              <a:ext uri="{FF2B5EF4-FFF2-40B4-BE49-F238E27FC236}">
-                <a16:creationId xmlns:a16="http://schemas.microsoft.com/office/drawing/2014/main" id="{A379C7B1-CFAD-4697-8869-AB5268C57234}"/>
+          <p:cNvPr id="6" name="social-flow-rule">
+            <a:extLst xmlns:a="http://schemas.openxmlformats.org/drawingml/2006/main">
+              <a:ext uri="{FF2B5EF4-FFF2-40B4-BE49-F238E27FC236}">
+                <a16:creationId xmlns:a16="http://schemas.microsoft.com/office/drawing/2014/main" id="{C19283FE-C11D-4DA7-AFEA-5F1D964BF108}"/>
               </a:ext>
             </a:extLst>
           </p:cNvPr>
@@ -1507,7 +1449,7 @@
         </p:nvSpPr>
         <p:spPr>
           <a:xfrm xmlns:a="http://schemas.openxmlformats.org/drawingml/2006/main" flipH="0" flipV="0">
-            <a:off x="6705600" y="1457325"/>
+            <a:off x="6705600" y="1143000"/>
             <a:ext cx="4057650" cy="9525"/>
           </a:xfrm>
           <a:prstGeom xmlns:a="http://schemas.openxmlformats.org/drawingml/2006/main" prst="line">
@@ -1524,10 +1466,10 @@
       </p:sp>
       <p:sp>
         <p:nvSpPr>
-          <p:cNvPr id="8" name="social-arrow-1">
-            <a:extLst xmlns:a="http://schemas.openxmlformats.org/drawingml/2006/main">
-              <a:ext uri="{FF2B5EF4-FFF2-40B4-BE49-F238E27FC236}">
-                <a16:creationId xmlns:a16="http://schemas.microsoft.com/office/drawing/2014/main" id="{F29B1064-708C-47D2-A535-6E719F0CD0A4}"/>
+          <p:cNvPr id="7" name="social-arrow-1">
+            <a:extLst xmlns:a="http://schemas.openxmlformats.org/drawingml/2006/main">
+              <a:ext uri="{FF2B5EF4-FFF2-40B4-BE49-F238E27FC236}">
+                <a16:creationId xmlns:a16="http://schemas.microsoft.com/office/drawing/2014/main" id="{4AEFE8D2-62DF-44F4-9F62-0F44FB8A1772}"/>
               </a:ext>
             </a:extLst>
           </p:cNvPr>
@@ -1538,7 +1480,7 @@
         </p:nvSpPr>
         <p:spPr>
           <a:xfrm xmlns:a="http://schemas.openxmlformats.org/drawingml/2006/main" rot="0">
-            <a:off x="7677150" y="2733675"/>
+            <a:off x="7677150" y="2419350"/>
             <a:ext cx="400050" cy="228600"/>
           </a:xfrm>
           <a:prstGeom xmlns:a="http://schemas.openxmlformats.org/drawingml/2006/main" prst="rightArrow">
@@ -1555,10 +1497,10 @@
       </p:sp>
       <p:sp>
         <p:nvSpPr>
-          <p:cNvPr id="9" name="social-arrow-2">
-            <a:extLst xmlns:a="http://schemas.openxmlformats.org/drawingml/2006/main">
-              <a:ext uri="{FF2B5EF4-FFF2-40B4-BE49-F238E27FC236}">
-                <a16:creationId xmlns:a16="http://schemas.microsoft.com/office/drawing/2014/main" id="{E4517AB4-F060-47C3-AD9A-42828653F028}"/>
+          <p:cNvPr id="8" name="social-arrow-2">
+            <a:extLst xmlns:a="http://schemas.openxmlformats.org/drawingml/2006/main">
+              <a:ext uri="{FF2B5EF4-FFF2-40B4-BE49-F238E27FC236}">
+                <a16:creationId xmlns:a16="http://schemas.microsoft.com/office/drawing/2014/main" id="{B357613B-D11E-454F-BAE2-98E72FAC42B0}"/>
               </a:ext>
             </a:extLst>
           </p:cNvPr>
@@ -1569,7 +1511,7 @@
         </p:nvSpPr>
         <p:spPr>
           <a:xfrm xmlns:a="http://schemas.openxmlformats.org/drawingml/2006/main" rot="0">
-            <a:off x="9182100" y="2733675"/>
+            <a:off x="9182100" y="2419350"/>
             <a:ext cx="400050" cy="228600"/>
           </a:xfrm>
           <a:prstGeom xmlns:a="http://schemas.openxmlformats.org/drawingml/2006/main" prst="rightArrow">
@@ -1586,10 +1528,10 @@
       </p:sp>
       <p:sp>
         <p:nvSpPr>
-          <p:cNvPr id="10" name="social-candidate-sheet">
-            <a:extLst xmlns:a="http://schemas.openxmlformats.org/drawingml/2006/main">
-              <a:ext uri="{FF2B5EF4-FFF2-40B4-BE49-F238E27FC236}">
-                <a16:creationId xmlns:a16="http://schemas.microsoft.com/office/drawing/2014/main" id="{AFAB7C83-AD17-47AE-8113-125E67A452FF}"/>
+          <p:cNvPr id="9" name="social-candidate-sheet">
+            <a:extLst xmlns:a="http://schemas.openxmlformats.org/drawingml/2006/main">
+              <a:ext uri="{FF2B5EF4-FFF2-40B4-BE49-F238E27FC236}">
+                <a16:creationId xmlns:a16="http://schemas.microsoft.com/office/drawing/2014/main" id="{D24E28F8-1FE4-4F37-B4D8-46F09AB57D73}"/>
               </a:ext>
             </a:extLst>
           </p:cNvPr>
@@ -1600,7 +1542,7 @@
         </p:nvSpPr>
         <p:spPr>
           <a:xfrm xmlns:a="http://schemas.openxmlformats.org/drawingml/2006/main" rot="0">
-            <a:off x="6705600" y="2028825"/>
+            <a:off x="6705600" y="1714500"/>
             <a:ext cx="952500" cy="1638300"/>
           </a:xfrm>
           <a:prstGeom xmlns:a="http://schemas.openxmlformats.org/drawingml/2006/main" prst="rect">
@@ -1619,10 +1561,10 @@
       </p:sp>
       <p:sp>
         <p:nvSpPr>
-          <p:cNvPr id="11" name="social-candidate-header">
-            <a:extLst xmlns:a="http://schemas.openxmlformats.org/drawingml/2006/main">
-              <a:ext uri="{FF2B5EF4-FFF2-40B4-BE49-F238E27FC236}">
-                <a16:creationId xmlns:a16="http://schemas.microsoft.com/office/drawing/2014/main" id="{7EDE2F86-23EC-43D3-B702-2BBCC94192E2}"/>
+          <p:cNvPr id="10" name="social-candidate-header">
+            <a:extLst xmlns:a="http://schemas.openxmlformats.org/drawingml/2006/main">
+              <a:ext uri="{FF2B5EF4-FFF2-40B4-BE49-F238E27FC236}">
+                <a16:creationId xmlns:a16="http://schemas.microsoft.com/office/drawing/2014/main" id="{5D06D578-A20B-42A2-83F3-BA94A8854C9F}"/>
               </a:ext>
             </a:extLst>
           </p:cNvPr>
@@ -1633,7 +1575,7 @@
         </p:nvSpPr>
         <p:spPr>
           <a:xfrm xmlns:a="http://schemas.openxmlformats.org/drawingml/2006/main" rot="0">
-            <a:off x="6705600" y="2028825"/>
+            <a:off x="6705600" y="1714500"/>
             <a:ext cx="952500" cy="285750"/>
           </a:xfrm>
           <a:prstGeom xmlns:a="http://schemas.openxmlformats.org/drawingml/2006/main" prst="rect">
@@ -1652,10 +1594,10 @@
       </p:sp>
       <p:sp>
         <p:nvSpPr>
-          <p:cNvPr id="12" name="social-candidate-1">
-            <a:extLst xmlns:a="http://schemas.openxmlformats.org/drawingml/2006/main">
-              <a:ext uri="{FF2B5EF4-FFF2-40B4-BE49-F238E27FC236}">
-                <a16:creationId xmlns:a16="http://schemas.microsoft.com/office/drawing/2014/main" id="{1DBE70C7-2D76-44A6-8E24-AEF5155CD655}"/>
+          <p:cNvPr id="11" name="social-candidate-1">
+            <a:extLst xmlns:a="http://schemas.openxmlformats.org/drawingml/2006/main">
+              <a:ext uri="{FF2B5EF4-FFF2-40B4-BE49-F238E27FC236}">
+                <a16:creationId xmlns:a16="http://schemas.microsoft.com/office/drawing/2014/main" id="{1F80EC94-0BE8-4A64-BFFA-F1CDDAC2E662}"/>
               </a:ext>
             </a:extLst>
           </p:cNvPr>
@@ -1666,7 +1608,7 @@
         </p:nvSpPr>
         <p:spPr>
           <a:xfrm xmlns:a="http://schemas.openxmlformats.org/drawingml/2006/main" rot="0">
-            <a:off x="6858000" y="2486025"/>
+            <a:off x="6858000" y="2171700"/>
             <a:ext cx="171450" cy="171450"/>
           </a:xfrm>
           <a:prstGeom xmlns:a="http://schemas.openxmlformats.org/drawingml/2006/main" prst="rect">
@@ -1683,10 +1625,10 @@
       </p:sp>
       <p:sp>
         <p:nvSpPr>
-          <p:cNvPr id="13" name="social-candidate-line-1">
-            <a:extLst xmlns:a="http://schemas.openxmlformats.org/drawingml/2006/main">
-              <a:ext uri="{FF2B5EF4-FFF2-40B4-BE49-F238E27FC236}">
-                <a16:creationId xmlns:a16="http://schemas.microsoft.com/office/drawing/2014/main" id="{7851645C-F4DB-47EF-9392-A126F3510652}"/>
+          <p:cNvPr id="12" name="social-candidate-line-1">
+            <a:extLst xmlns:a="http://schemas.openxmlformats.org/drawingml/2006/main">
+              <a:ext uri="{FF2B5EF4-FFF2-40B4-BE49-F238E27FC236}">
+                <a16:creationId xmlns:a16="http://schemas.microsoft.com/office/drawing/2014/main" id="{CF0423BE-88CE-49B4-812D-5653A3423903}"/>
               </a:ext>
             </a:extLst>
           </p:cNvPr>
@@ -1697,7 +1639,7 @@
         </p:nvSpPr>
         <p:spPr>
           <a:xfrm xmlns:a="http://schemas.openxmlformats.org/drawingml/2006/main" flipH="0" flipV="0">
-            <a:off x="7143750" y="2571750"/>
+            <a:off x="7143750" y="2257425"/>
             <a:ext cx="342900" cy="9525"/>
           </a:xfrm>
           <a:prstGeom xmlns:a="http://schemas.openxmlformats.org/drawingml/2006/main" prst="line">
@@ -1714,10 +1656,10 @@
       </p:sp>
       <p:sp>
         <p:nvSpPr>
-          <p:cNvPr id="14" name="social-candidate-2">
-            <a:extLst xmlns:a="http://schemas.openxmlformats.org/drawingml/2006/main">
-              <a:ext uri="{FF2B5EF4-FFF2-40B4-BE49-F238E27FC236}">
-                <a16:creationId xmlns:a16="http://schemas.microsoft.com/office/drawing/2014/main" id="{8CB0FA18-8128-43BE-83AA-55DF14E6D272}"/>
+          <p:cNvPr id="13" name="social-candidate-2">
+            <a:extLst xmlns:a="http://schemas.openxmlformats.org/drawingml/2006/main">
+              <a:ext uri="{FF2B5EF4-FFF2-40B4-BE49-F238E27FC236}">
+                <a16:creationId xmlns:a16="http://schemas.microsoft.com/office/drawing/2014/main" id="{DD83CF19-A3AD-4D23-BFD8-CB42A250D8E1}"/>
               </a:ext>
             </a:extLst>
           </p:cNvPr>
@@ -1728,7 +1670,7 @@
         </p:nvSpPr>
         <p:spPr>
           <a:xfrm xmlns:a="http://schemas.openxmlformats.org/drawingml/2006/main" rot="0">
-            <a:off x="6858000" y="2847975"/>
+            <a:off x="6858000" y="2533650"/>
             <a:ext cx="171450" cy="171450"/>
           </a:xfrm>
           <a:prstGeom xmlns:a="http://schemas.openxmlformats.org/drawingml/2006/main" prst="ellipse">
@@ -1747,10 +1689,10 @@
       </p:sp>
       <p:sp>
         <p:nvSpPr>
-          <p:cNvPr id="15" name="social-candidate-line-2">
-            <a:extLst xmlns:a="http://schemas.openxmlformats.org/drawingml/2006/main">
-              <a:ext uri="{FF2B5EF4-FFF2-40B4-BE49-F238E27FC236}">
-                <a16:creationId xmlns:a16="http://schemas.microsoft.com/office/drawing/2014/main" id="{5C243D5E-2A3F-4F3A-9B4E-E756EE4096B5}"/>
+          <p:cNvPr id="14" name="social-candidate-line-2">
+            <a:extLst xmlns:a="http://schemas.openxmlformats.org/drawingml/2006/main">
+              <a:ext uri="{FF2B5EF4-FFF2-40B4-BE49-F238E27FC236}">
+                <a16:creationId xmlns:a16="http://schemas.microsoft.com/office/drawing/2014/main" id="{774C598A-1E67-4AAF-BFF4-D9B86CA9D309}"/>
               </a:ext>
             </a:extLst>
           </p:cNvPr>
@@ -1761,7 +1703,7 @@
         </p:nvSpPr>
         <p:spPr>
           <a:xfrm xmlns:a="http://schemas.openxmlformats.org/drawingml/2006/main" flipH="0" flipV="0">
-            <a:off x="7143750" y="2933700"/>
+            <a:off x="7143750" y="2619375"/>
             <a:ext cx="342900" cy="9525"/>
           </a:xfrm>
           <a:prstGeom xmlns:a="http://schemas.openxmlformats.org/drawingml/2006/main" prst="line">
@@ -1778,10 +1720,10 @@
       </p:sp>
       <p:sp>
         <p:nvSpPr>
-          <p:cNvPr id="16" name="social-candidate-3">
-            <a:extLst xmlns:a="http://schemas.openxmlformats.org/drawingml/2006/main">
-              <a:ext uri="{FF2B5EF4-FFF2-40B4-BE49-F238E27FC236}">
-                <a16:creationId xmlns:a16="http://schemas.microsoft.com/office/drawing/2014/main" id="{0D647C07-66E0-4DB3-84F2-5C3972194A89}"/>
+          <p:cNvPr id="15" name="social-candidate-3">
+            <a:extLst xmlns:a="http://schemas.openxmlformats.org/drawingml/2006/main">
+              <a:ext uri="{FF2B5EF4-FFF2-40B4-BE49-F238E27FC236}">
+                <a16:creationId xmlns:a16="http://schemas.microsoft.com/office/drawing/2014/main" id="{C1D66C61-164B-4A7A-8D03-999E30A70BE7}"/>
               </a:ext>
             </a:extLst>
           </p:cNvPr>
@@ -1792,7 +1734,7 @@
         </p:nvSpPr>
         <p:spPr>
           <a:xfrm xmlns:a="http://schemas.openxmlformats.org/drawingml/2006/main" rot="0">
-            <a:off x="6858000" y="3209925"/>
+            <a:off x="6858000" y="2895600"/>
             <a:ext cx="171450" cy="171450"/>
           </a:xfrm>
           <a:prstGeom xmlns:a="http://schemas.openxmlformats.org/drawingml/2006/main" prst="diamond">
@@ -1811,10 +1753,10 @@
       </p:sp>
       <p:sp>
         <p:nvSpPr>
-          <p:cNvPr id="17" name="social-candidate-line-3">
-            <a:extLst xmlns:a="http://schemas.openxmlformats.org/drawingml/2006/main">
-              <a:ext uri="{FF2B5EF4-FFF2-40B4-BE49-F238E27FC236}">
-                <a16:creationId xmlns:a16="http://schemas.microsoft.com/office/drawing/2014/main" id="{AE0F7B28-19EF-4A0B-94E5-9ED5650D7378}"/>
+          <p:cNvPr id="16" name="social-candidate-line-3">
+            <a:extLst xmlns:a="http://schemas.openxmlformats.org/drawingml/2006/main">
+              <a:ext uri="{FF2B5EF4-FFF2-40B4-BE49-F238E27FC236}">
+                <a16:creationId xmlns:a16="http://schemas.microsoft.com/office/drawing/2014/main" id="{4D3BDA70-3BAC-431C-A11B-516554A4E2E2}"/>
               </a:ext>
             </a:extLst>
           </p:cNvPr>
@@ -1825,7 +1767,7 @@
         </p:nvSpPr>
         <p:spPr>
           <a:xfrm xmlns:a="http://schemas.openxmlformats.org/drawingml/2006/main" flipH="0" flipV="0">
-            <a:off x="7143750" y="3295650"/>
+            <a:off x="7143750" y="2981325"/>
             <a:ext cx="342900" cy="9525"/>
           </a:xfrm>
           <a:prstGeom xmlns:a="http://schemas.openxmlformats.org/drawingml/2006/main" prst="line">
@@ -1842,10 +1784,10 @@
       </p:sp>
       <p:sp>
         <p:nvSpPr>
-          <p:cNvPr id="18" name="social-fixed-label">
-            <a:extLst xmlns:a="http://schemas.openxmlformats.org/drawingml/2006/main">
-              <a:ext uri="{FF2B5EF4-FFF2-40B4-BE49-F238E27FC236}">
-                <a16:creationId xmlns:a16="http://schemas.microsoft.com/office/drawing/2014/main" id="{F6D537F0-FD82-4A66-A141-9C1B8021AEDC}"/>
+          <p:cNvPr id="17" name="social-fixed-label">
+            <a:extLst xmlns:a="http://schemas.openxmlformats.org/drawingml/2006/main">
+              <a:ext uri="{FF2B5EF4-FFF2-40B4-BE49-F238E27FC236}">
+                <a16:creationId xmlns:a16="http://schemas.microsoft.com/office/drawing/2014/main" id="{E5C9372D-904F-4912-BDD3-33319452C575}"/>
               </a:ext>
             </a:extLst>
           </p:cNvPr>
@@ -1856,7 +1798,7 @@
         </p:nvSpPr>
         <p:spPr>
           <a:xfrm xmlns:a="http://schemas.openxmlformats.org/drawingml/2006/main" rot="0">
-            <a:off x="8143875" y="2257425"/>
+            <a:off x="8143875" y="1943100"/>
             <a:ext cx="981075" cy="228600"/>
           </a:xfrm>
           <a:prstGeom xmlns:a="http://schemas.openxmlformats.org/drawingml/2006/main" prst="rect">
@@ -1900,10 +1842,10 @@
       </p:sp>
       <p:sp>
         <p:nvSpPr>
-          <p:cNvPr id="19" name="social-slot-1">
-            <a:extLst xmlns:a="http://schemas.openxmlformats.org/drawingml/2006/main">
-              <a:ext uri="{FF2B5EF4-FFF2-40B4-BE49-F238E27FC236}">
-                <a16:creationId xmlns:a16="http://schemas.microsoft.com/office/drawing/2014/main" id="{AD869BF2-F5AF-4A27-8D98-7EC6BBF8A696}"/>
+          <p:cNvPr id="18" name="social-slot-1">
+            <a:extLst xmlns:a="http://schemas.openxmlformats.org/drawingml/2006/main">
+              <a:ext uri="{FF2B5EF4-FFF2-40B4-BE49-F238E27FC236}">
+                <a16:creationId xmlns:a16="http://schemas.microsoft.com/office/drawing/2014/main" id="{E6099278-8879-414E-90C5-4B5FD60DCAD9}"/>
               </a:ext>
             </a:extLst>
           </p:cNvPr>
@@ -1914,7 +1856,7 @@
         </p:nvSpPr>
         <p:spPr>
           <a:xfrm xmlns:a="http://schemas.openxmlformats.org/drawingml/2006/main" rot="0">
-            <a:off x="8134350" y="2581275"/>
+            <a:off x="8134350" y="2266950"/>
             <a:ext cx="457200" cy="457200"/>
           </a:xfrm>
           <a:prstGeom xmlns:a="http://schemas.openxmlformats.org/drawingml/2006/main" prst="rect">
@@ -1933,10 +1875,10 @@
       </p:sp>
       <p:sp>
         <p:nvSpPr>
-          <p:cNvPr id="20" name="social-slot-token-1">
-            <a:extLst xmlns:a="http://schemas.openxmlformats.org/drawingml/2006/main">
-              <a:ext uri="{FF2B5EF4-FFF2-40B4-BE49-F238E27FC236}">
-                <a16:creationId xmlns:a16="http://schemas.microsoft.com/office/drawing/2014/main" id="{C4C05C6D-6BD1-4B66-A28A-7DBDF99B613A}"/>
+          <p:cNvPr id="19" name="social-slot-token-1">
+            <a:extLst xmlns:a="http://schemas.openxmlformats.org/drawingml/2006/main">
+              <a:ext uri="{FF2B5EF4-FFF2-40B4-BE49-F238E27FC236}">
+                <a16:creationId xmlns:a16="http://schemas.microsoft.com/office/drawing/2014/main" id="{22ED2FC1-E0D4-4449-9C26-1FB2F17EB2F0}"/>
               </a:ext>
             </a:extLst>
           </p:cNvPr>
@@ -1947,7 +1889,7 @@
         </p:nvSpPr>
         <p:spPr>
           <a:xfrm xmlns:a="http://schemas.openxmlformats.org/drawingml/2006/main" rot="0">
-            <a:off x="8267700" y="2714625"/>
+            <a:off x="8267700" y="2400300"/>
             <a:ext cx="190500" cy="190500"/>
           </a:xfrm>
           <a:prstGeom xmlns:a="http://schemas.openxmlformats.org/drawingml/2006/main" prst="ellipse">
@@ -1966,10 +1908,10 @@
       </p:sp>
       <p:sp>
         <p:nvSpPr>
-          <p:cNvPr id="21" name="social-slot-2">
-            <a:extLst xmlns:a="http://schemas.openxmlformats.org/drawingml/2006/main">
-              <a:ext uri="{FF2B5EF4-FFF2-40B4-BE49-F238E27FC236}">
-                <a16:creationId xmlns:a16="http://schemas.microsoft.com/office/drawing/2014/main" id="{D6E48348-32BF-410F-BD07-0311850A47E0}"/>
+          <p:cNvPr id="20" name="social-slot-2">
+            <a:extLst xmlns:a="http://schemas.openxmlformats.org/drawingml/2006/main">
+              <a:ext uri="{FF2B5EF4-FFF2-40B4-BE49-F238E27FC236}">
+                <a16:creationId xmlns:a16="http://schemas.microsoft.com/office/drawing/2014/main" id="{B3FB0FAA-77A2-4DD9-9907-BA653DBFE571}"/>
               </a:ext>
             </a:extLst>
           </p:cNvPr>
@@ -1980,7 +1922,7 @@
         </p:nvSpPr>
         <p:spPr>
           <a:xfrm xmlns:a="http://schemas.openxmlformats.org/drawingml/2006/main" rot="0">
-            <a:off x="8648700" y="2581275"/>
+            <a:off x="8648700" y="2266950"/>
             <a:ext cx="457200" cy="457200"/>
           </a:xfrm>
           <a:prstGeom xmlns:a="http://schemas.openxmlformats.org/drawingml/2006/main" prst="rect">
@@ -1999,10 +1941,10 @@
       </p:sp>
       <p:sp>
         <p:nvSpPr>
-          <p:cNvPr id="22" name="social-slot-token-2">
-            <a:extLst xmlns:a="http://schemas.openxmlformats.org/drawingml/2006/main">
-              <a:ext uri="{FF2B5EF4-FFF2-40B4-BE49-F238E27FC236}">
-                <a16:creationId xmlns:a16="http://schemas.microsoft.com/office/drawing/2014/main" id="{E6DE089E-3E91-4CFD-B5E0-0A29F19DD4E0}"/>
+          <p:cNvPr id="21" name="social-slot-token-2">
+            <a:extLst xmlns:a="http://schemas.openxmlformats.org/drawingml/2006/main">
+              <a:ext uri="{FF2B5EF4-FFF2-40B4-BE49-F238E27FC236}">
+                <a16:creationId xmlns:a16="http://schemas.microsoft.com/office/drawing/2014/main" id="{DD4CEAFD-3736-4929-AA08-DA33DF77637A}"/>
               </a:ext>
             </a:extLst>
           </p:cNvPr>
@@ -2013,7 +1955,7 @@
         </p:nvSpPr>
         <p:spPr>
           <a:xfrm xmlns:a="http://schemas.openxmlformats.org/drawingml/2006/main" rot="0">
-            <a:off x="8782050" y="2714625"/>
+            <a:off x="8782050" y="2400300"/>
             <a:ext cx="190500" cy="190500"/>
           </a:xfrm>
           <a:prstGeom xmlns:a="http://schemas.openxmlformats.org/drawingml/2006/main" prst="diamond">
@@ -2032,10 +1974,10 @@
       </p:sp>
       <p:sp>
         <p:nvSpPr>
-          <p:cNvPr id="23" name="social-slot-3">
-            <a:extLst xmlns:a="http://schemas.openxmlformats.org/drawingml/2006/main">
-              <a:ext uri="{FF2B5EF4-FFF2-40B4-BE49-F238E27FC236}">
-                <a16:creationId xmlns:a16="http://schemas.microsoft.com/office/drawing/2014/main" id="{6B5694D8-1F5C-4F4B-B706-B541E4CE4117}"/>
+          <p:cNvPr id="22" name="social-slot-3">
+            <a:extLst xmlns:a="http://schemas.openxmlformats.org/drawingml/2006/main">
+              <a:ext uri="{FF2B5EF4-FFF2-40B4-BE49-F238E27FC236}">
+                <a16:creationId xmlns:a16="http://schemas.microsoft.com/office/drawing/2014/main" id="{F803E0C4-EB6B-42EC-B8BC-BEA64A17ED7F}"/>
               </a:ext>
             </a:extLst>
           </p:cNvPr>
@@ -2046,7 +1988,7 @@
         </p:nvSpPr>
         <p:spPr>
           <a:xfrm xmlns:a="http://schemas.openxmlformats.org/drawingml/2006/main" rot="0">
-            <a:off x="8134350" y="3095625"/>
+            <a:off x="8134350" y="2781300"/>
             <a:ext cx="457200" cy="457200"/>
           </a:xfrm>
           <a:prstGeom xmlns:a="http://schemas.openxmlformats.org/drawingml/2006/main" prst="rect">
@@ -2065,10 +2007,10 @@
       </p:sp>
       <p:sp>
         <p:nvSpPr>
-          <p:cNvPr id="24" name="social-slot-token-3">
-            <a:extLst xmlns:a="http://schemas.openxmlformats.org/drawingml/2006/main">
-              <a:ext uri="{FF2B5EF4-FFF2-40B4-BE49-F238E27FC236}">
-                <a16:creationId xmlns:a16="http://schemas.microsoft.com/office/drawing/2014/main" id="{867F54EC-866E-4046-BB5F-AF60354A9149}"/>
+          <p:cNvPr id="23" name="social-slot-token-3">
+            <a:extLst xmlns:a="http://schemas.openxmlformats.org/drawingml/2006/main">
+              <a:ext uri="{FF2B5EF4-FFF2-40B4-BE49-F238E27FC236}">
+                <a16:creationId xmlns:a16="http://schemas.microsoft.com/office/drawing/2014/main" id="{064E5667-EA48-4176-A8E3-BF68FD7E36DF}"/>
               </a:ext>
             </a:extLst>
           </p:cNvPr>
@@ -2079,7 +2021,7 @@
         </p:nvSpPr>
         <p:spPr>
           <a:xfrm xmlns:a="http://schemas.openxmlformats.org/drawingml/2006/main" rot="0">
-            <a:off x="8267700" y="3228975"/>
+            <a:off x="8267700" y="2914650"/>
             <a:ext cx="190500" cy="190500"/>
           </a:xfrm>
           <a:prstGeom xmlns:a="http://schemas.openxmlformats.org/drawingml/2006/main" prst="rect">
@@ -2096,10 +2038,10 @@
       </p:sp>
       <p:sp>
         <p:nvSpPr>
-          <p:cNvPr id="25" name="social-slot-4">
-            <a:extLst xmlns:a="http://schemas.openxmlformats.org/drawingml/2006/main">
-              <a:ext uri="{FF2B5EF4-FFF2-40B4-BE49-F238E27FC236}">
-                <a16:creationId xmlns:a16="http://schemas.microsoft.com/office/drawing/2014/main" id="{52176730-6D9E-4A9A-BF47-891DB61B0CD3}"/>
+          <p:cNvPr id="24" name="social-slot-4">
+            <a:extLst xmlns:a="http://schemas.openxmlformats.org/drawingml/2006/main">
+              <a:ext uri="{FF2B5EF4-FFF2-40B4-BE49-F238E27FC236}">
+                <a16:creationId xmlns:a16="http://schemas.microsoft.com/office/drawing/2014/main" id="{E4AEC0E9-EEBC-419C-B487-48F5301FDB8D}"/>
               </a:ext>
             </a:extLst>
           </p:cNvPr>
@@ -2110,7 +2052,7 @@
         </p:nvSpPr>
         <p:spPr>
           <a:xfrm xmlns:a="http://schemas.openxmlformats.org/drawingml/2006/main" rot="0">
-            <a:off x="8648700" y="3095625"/>
+            <a:off x="8648700" y="2781300"/>
             <a:ext cx="457200" cy="457200"/>
           </a:xfrm>
           <a:prstGeom xmlns:a="http://schemas.openxmlformats.org/drawingml/2006/main" prst="rect">
@@ -2129,10 +2071,10 @@
       </p:sp>
       <p:sp>
         <p:nvSpPr>
-          <p:cNvPr id="26" name="social-slot-token-4">
-            <a:extLst xmlns:a="http://schemas.openxmlformats.org/drawingml/2006/main">
-              <a:ext uri="{FF2B5EF4-FFF2-40B4-BE49-F238E27FC236}">
-                <a16:creationId xmlns:a16="http://schemas.microsoft.com/office/drawing/2014/main" id="{4DEEC3D9-4F00-4632-8EEC-EBAA64A97543}"/>
+          <p:cNvPr id="25" name="social-slot-token-4">
+            <a:extLst xmlns:a="http://schemas.openxmlformats.org/drawingml/2006/main">
+              <a:ext uri="{FF2B5EF4-FFF2-40B4-BE49-F238E27FC236}">
+                <a16:creationId xmlns:a16="http://schemas.microsoft.com/office/drawing/2014/main" id="{5D0EFF2E-D59F-42C8-90EB-A915E1166676}"/>
               </a:ext>
             </a:extLst>
           </p:cNvPr>
@@ -2143,7 +2085,7 @@
         </p:nvSpPr>
         <p:spPr>
           <a:xfrm xmlns:a="http://schemas.openxmlformats.org/drawingml/2006/main" rot="0">
-            <a:off x="8782050" y="3228975"/>
+            <a:off x="8782050" y="2914650"/>
             <a:ext cx="190500" cy="190500"/>
           </a:xfrm>
           <a:prstGeom xmlns:a="http://schemas.openxmlformats.org/drawingml/2006/main" prst="ellipse">
@@ -2162,10 +2104,10 @@
       </p:sp>
       <p:sp>
         <p:nvSpPr>
-          <p:cNvPr id="27" name="social-ledger">
-            <a:extLst xmlns:a="http://schemas.openxmlformats.org/drawingml/2006/main">
-              <a:ext uri="{FF2B5EF4-FFF2-40B4-BE49-F238E27FC236}">
-                <a16:creationId xmlns:a16="http://schemas.microsoft.com/office/drawing/2014/main" id="{5A98CAEF-6E14-407D-AD7E-A0A2D23B97AF}"/>
+          <p:cNvPr id="26" name="social-ledger">
+            <a:extLst xmlns:a="http://schemas.openxmlformats.org/drawingml/2006/main">
+              <a:ext uri="{FF2B5EF4-FFF2-40B4-BE49-F238E27FC236}">
+                <a16:creationId xmlns:a16="http://schemas.microsoft.com/office/drawing/2014/main" id="{1328D2D4-3BB6-4B30-BE74-6AE6C32E1734}"/>
               </a:ext>
             </a:extLst>
           </p:cNvPr>
@@ -2176,7 +2118,7 @@
         </p:nvSpPr>
         <p:spPr>
           <a:xfrm xmlns:a="http://schemas.openxmlformats.org/drawingml/2006/main" rot="0">
-            <a:off x="9601200" y="2028825"/>
+            <a:off x="9601200" y="1714500"/>
             <a:ext cx="1162050" cy="1638300"/>
           </a:xfrm>
           <a:prstGeom xmlns:a="http://schemas.openxmlformats.org/drawingml/2006/main" prst="rect">
@@ -2195,10 +2137,10 @@
       </p:sp>
       <p:sp>
         <p:nvSpPr>
-          <p:cNvPr id="28" name="social-ledger-header">
-            <a:extLst xmlns:a="http://schemas.openxmlformats.org/drawingml/2006/main">
-              <a:ext uri="{FF2B5EF4-FFF2-40B4-BE49-F238E27FC236}">
-                <a16:creationId xmlns:a16="http://schemas.microsoft.com/office/drawing/2014/main" id="{79AAB96F-87BC-422B-B8D8-8318570F8C48}"/>
+          <p:cNvPr id="27" name="social-ledger-header">
+            <a:extLst xmlns:a="http://schemas.openxmlformats.org/drawingml/2006/main">
+              <a:ext uri="{FF2B5EF4-FFF2-40B4-BE49-F238E27FC236}">
+                <a16:creationId xmlns:a16="http://schemas.microsoft.com/office/drawing/2014/main" id="{5F07399E-E3EC-447B-AB6A-F29B1096C72D}"/>
               </a:ext>
             </a:extLst>
           </p:cNvPr>
@@ -2209,7 +2151,7 @@
         </p:nvSpPr>
         <p:spPr>
           <a:xfrm xmlns:a="http://schemas.openxmlformats.org/drawingml/2006/main" rot="0">
-            <a:off x="9601200" y="2028825"/>
+            <a:off x="9601200" y="1714500"/>
             <a:ext cx="1162050" cy="285750"/>
           </a:xfrm>
           <a:prstGeom xmlns:a="http://schemas.openxmlformats.org/drawingml/2006/main" prst="rect">
@@ -2228,10 +2170,10 @@
       </p:sp>
       <p:sp>
         <p:nvSpPr>
-          <p:cNvPr id="29" name="social-ledger-check-1-circle">
-            <a:extLst xmlns:a="http://schemas.openxmlformats.org/drawingml/2006/main">
-              <a:ext uri="{FF2B5EF4-FFF2-40B4-BE49-F238E27FC236}">
-                <a16:creationId xmlns:a16="http://schemas.microsoft.com/office/drawing/2014/main" id="{34508232-7E4F-413D-8808-71D8299571FB}"/>
+          <p:cNvPr id="28" name="social-ledger-check-1-circle">
+            <a:extLst xmlns:a="http://schemas.openxmlformats.org/drawingml/2006/main">
+              <a:ext uri="{FF2B5EF4-FFF2-40B4-BE49-F238E27FC236}">
+                <a16:creationId xmlns:a16="http://schemas.microsoft.com/office/drawing/2014/main" id="{A378F2B9-0D8C-4752-8444-0C83741ADD7C}"/>
               </a:ext>
             </a:extLst>
           </p:cNvPr>
@@ -2242,7 +2184,7 @@
         </p:nvSpPr>
         <p:spPr>
           <a:xfrm xmlns:a="http://schemas.openxmlformats.org/drawingml/2006/main" rot="0">
-            <a:off x="9753600" y="2486025"/>
+            <a:off x="9753600" y="2171700"/>
             <a:ext cx="190500" cy="190500"/>
           </a:xfrm>
           <a:prstGeom xmlns:a="http://schemas.openxmlformats.org/drawingml/2006/main" prst="ellipse">
@@ -2261,10 +2203,10 @@
       </p:sp>
       <p:sp>
         <p:nvSpPr>
-          <p:cNvPr id="30" name="social-ledger-check-1-left">
-            <a:extLst xmlns:a="http://schemas.openxmlformats.org/drawingml/2006/main">
-              <a:ext uri="{FF2B5EF4-FFF2-40B4-BE49-F238E27FC236}">
-                <a16:creationId xmlns:a16="http://schemas.microsoft.com/office/drawing/2014/main" id="{6663B54B-E027-4CD6-966B-E8339F8A87C4}"/>
+          <p:cNvPr id="29" name="social-ledger-check-1-left">
+            <a:extLst xmlns:a="http://schemas.openxmlformats.org/drawingml/2006/main">
+              <a:ext uri="{FF2B5EF4-FFF2-40B4-BE49-F238E27FC236}">
+                <a16:creationId xmlns:a16="http://schemas.microsoft.com/office/drawing/2014/main" id="{C0F4CAB8-E71D-464B-905A-DD4ED67E5CCD}"/>
               </a:ext>
             </a:extLst>
           </p:cNvPr>
@@ -2275,7 +2217,7 @@
         </p:nvSpPr>
         <p:spPr>
           <a:xfrm xmlns:a="http://schemas.openxmlformats.org/drawingml/2006/main" flipH="0" flipV="0">
-            <a:off x="9801225" y="2581275"/>
+            <a:off x="9801225" y="2266950"/>
             <a:ext cx="38100" cy="38100"/>
           </a:xfrm>
           <a:prstGeom xmlns:a="http://schemas.openxmlformats.org/drawingml/2006/main" prst="line">
@@ -2292,10 +2234,10 @@
       </p:sp>
       <p:sp>
         <p:nvSpPr>
-          <p:cNvPr id="31" name="social-ledger-check-1-right">
-            <a:extLst xmlns:a="http://schemas.openxmlformats.org/drawingml/2006/main">
-              <a:ext uri="{FF2B5EF4-FFF2-40B4-BE49-F238E27FC236}">
-                <a16:creationId xmlns:a16="http://schemas.microsoft.com/office/drawing/2014/main" id="{4C5FB928-3013-42A3-8529-7F4B0E8E828F}"/>
+          <p:cNvPr id="30" name="social-ledger-check-1-right">
+            <a:extLst xmlns:a="http://schemas.openxmlformats.org/drawingml/2006/main">
+              <a:ext uri="{FF2B5EF4-FFF2-40B4-BE49-F238E27FC236}">
+                <a16:creationId xmlns:a16="http://schemas.microsoft.com/office/drawing/2014/main" id="{7BE3608B-DCE6-4863-AB7D-44D91340B630}"/>
               </a:ext>
             </a:extLst>
           </p:cNvPr>
@@ -2306,7 +2248,7 @@
         </p:nvSpPr>
         <p:spPr>
           <a:xfrm xmlns:a="http://schemas.openxmlformats.org/drawingml/2006/main" flipH="0" flipV="1">
-            <a:off x="9839325" y="2543175"/>
+            <a:off x="9839325" y="2228850"/>
             <a:ext cx="66675" cy="76200"/>
           </a:xfrm>
           <a:prstGeom xmlns:a="http://schemas.openxmlformats.org/drawingml/2006/main" prst="line">
@@ -2323,10 +2265,10 @@
       </p:sp>
       <p:sp>
         <p:nvSpPr>
-          <p:cNvPr id="32" name="social-ledger-line-1">
-            <a:extLst xmlns:a="http://schemas.openxmlformats.org/drawingml/2006/main">
-              <a:ext uri="{FF2B5EF4-FFF2-40B4-BE49-F238E27FC236}">
-                <a16:creationId xmlns:a16="http://schemas.microsoft.com/office/drawing/2014/main" id="{A23FCB1C-1FDC-4B53-B789-8691B9D597B8}"/>
+          <p:cNvPr id="31" name="social-ledger-line-1">
+            <a:extLst xmlns:a="http://schemas.openxmlformats.org/drawingml/2006/main">
+              <a:ext uri="{FF2B5EF4-FFF2-40B4-BE49-F238E27FC236}">
+                <a16:creationId xmlns:a16="http://schemas.microsoft.com/office/drawing/2014/main" id="{8576CF4A-2C01-40B4-8696-5DB6D5CBE936}"/>
               </a:ext>
             </a:extLst>
           </p:cNvPr>
@@ -2337,7 +2279,7 @@
         </p:nvSpPr>
         <p:spPr>
           <a:xfrm xmlns:a="http://schemas.openxmlformats.org/drawingml/2006/main" flipH="0" flipV="0">
-            <a:off x="10029825" y="2581275"/>
+            <a:off x="10029825" y="2266950"/>
             <a:ext cx="561975" cy="9525"/>
           </a:xfrm>
           <a:prstGeom xmlns:a="http://schemas.openxmlformats.org/drawingml/2006/main" prst="line">
@@ -2354,10 +2296,10 @@
       </p:sp>
       <p:sp>
         <p:nvSpPr>
-          <p:cNvPr id="33" name="social-ledger-check-2-circle">
-            <a:extLst xmlns:a="http://schemas.openxmlformats.org/drawingml/2006/main">
-              <a:ext uri="{FF2B5EF4-FFF2-40B4-BE49-F238E27FC236}">
-                <a16:creationId xmlns:a16="http://schemas.microsoft.com/office/drawing/2014/main" id="{35006BA7-BF5B-4A4D-A5F7-AB1B750AF5A0}"/>
+          <p:cNvPr id="32" name="social-ledger-check-2-circle">
+            <a:extLst xmlns:a="http://schemas.openxmlformats.org/drawingml/2006/main">
+              <a:ext uri="{FF2B5EF4-FFF2-40B4-BE49-F238E27FC236}">
+                <a16:creationId xmlns:a16="http://schemas.microsoft.com/office/drawing/2014/main" id="{A0FEF091-BA06-48BD-8BFD-D358587B7EAB}"/>
               </a:ext>
             </a:extLst>
           </p:cNvPr>
@@ -2368,7 +2310,7 @@
         </p:nvSpPr>
         <p:spPr>
           <a:xfrm xmlns:a="http://schemas.openxmlformats.org/drawingml/2006/main" rot="0">
-            <a:off x="9753600" y="2857500"/>
+            <a:off x="9753600" y="2543175"/>
             <a:ext cx="190500" cy="190500"/>
           </a:xfrm>
           <a:prstGeom xmlns:a="http://schemas.openxmlformats.org/drawingml/2006/main" prst="ellipse">
@@ -2387,10 +2329,10 @@
       </p:sp>
       <p:sp>
         <p:nvSpPr>
-          <p:cNvPr id="34" name="social-ledger-check-2-left">
-            <a:extLst xmlns:a="http://schemas.openxmlformats.org/drawingml/2006/main">
-              <a:ext uri="{FF2B5EF4-FFF2-40B4-BE49-F238E27FC236}">
-                <a16:creationId xmlns:a16="http://schemas.microsoft.com/office/drawing/2014/main" id="{6A763CAB-A7D5-4345-BA70-F5BCBE3E6FD1}"/>
+          <p:cNvPr id="33" name="social-ledger-check-2-left">
+            <a:extLst xmlns:a="http://schemas.openxmlformats.org/drawingml/2006/main">
+              <a:ext uri="{FF2B5EF4-FFF2-40B4-BE49-F238E27FC236}">
+                <a16:creationId xmlns:a16="http://schemas.microsoft.com/office/drawing/2014/main" id="{3456FB67-444E-4228-8029-5334218896A4}"/>
               </a:ext>
             </a:extLst>
           </p:cNvPr>
@@ -2401,7 +2343,7 @@
         </p:nvSpPr>
         <p:spPr>
           <a:xfrm xmlns:a="http://schemas.openxmlformats.org/drawingml/2006/main" flipH="0" flipV="0">
-            <a:off x="9801225" y="2952750"/>
+            <a:off x="9801225" y="2638425"/>
             <a:ext cx="38100" cy="38100"/>
           </a:xfrm>
           <a:prstGeom xmlns:a="http://schemas.openxmlformats.org/drawingml/2006/main" prst="line">
@@ -2418,10 +2360,10 @@
       </p:sp>
       <p:sp>
         <p:nvSpPr>
-          <p:cNvPr id="35" name="social-ledger-check-2-right">
-            <a:extLst xmlns:a="http://schemas.openxmlformats.org/drawingml/2006/main">
-              <a:ext uri="{FF2B5EF4-FFF2-40B4-BE49-F238E27FC236}">
-                <a16:creationId xmlns:a16="http://schemas.microsoft.com/office/drawing/2014/main" id="{676100D9-2F92-400F-AB15-56B099D67C53}"/>
+          <p:cNvPr id="34" name="social-ledger-check-2-right">
+            <a:extLst xmlns:a="http://schemas.openxmlformats.org/drawingml/2006/main">
+              <a:ext uri="{FF2B5EF4-FFF2-40B4-BE49-F238E27FC236}">
+                <a16:creationId xmlns:a16="http://schemas.microsoft.com/office/drawing/2014/main" id="{98262458-5C4F-44F8-9297-22D6BE3992A1}"/>
               </a:ext>
             </a:extLst>
           </p:cNvPr>
@@ -2432,7 +2374,7 @@
         </p:nvSpPr>
         <p:spPr>
           <a:xfrm xmlns:a="http://schemas.openxmlformats.org/drawingml/2006/main" flipH="0" flipV="1">
-            <a:off x="9839325" y="2914650"/>
+            <a:off x="9839325" y="2600325"/>
             <a:ext cx="66675" cy="76200"/>
           </a:xfrm>
           <a:prstGeom xmlns:a="http://schemas.openxmlformats.org/drawingml/2006/main" prst="line">
@@ -2449,10 +2391,10 @@
       </p:sp>
       <p:sp>
         <p:nvSpPr>
-          <p:cNvPr id="36" name="social-ledger-line-2">
-            <a:extLst xmlns:a="http://schemas.openxmlformats.org/drawingml/2006/main">
-              <a:ext uri="{FF2B5EF4-FFF2-40B4-BE49-F238E27FC236}">
-                <a16:creationId xmlns:a16="http://schemas.microsoft.com/office/drawing/2014/main" id="{7F952E76-CAE0-4443-A394-C5D8FCDAA017}"/>
+          <p:cNvPr id="35" name="social-ledger-line-2">
+            <a:extLst xmlns:a="http://schemas.openxmlformats.org/drawingml/2006/main">
+              <a:ext uri="{FF2B5EF4-FFF2-40B4-BE49-F238E27FC236}">
+                <a16:creationId xmlns:a16="http://schemas.microsoft.com/office/drawing/2014/main" id="{486721BC-3532-4ADE-88DF-D80C83C4232A}"/>
               </a:ext>
             </a:extLst>
           </p:cNvPr>
@@ -2463,7 +2405,7 @@
         </p:nvSpPr>
         <p:spPr>
           <a:xfrm xmlns:a="http://schemas.openxmlformats.org/drawingml/2006/main" flipH="0" flipV="0">
-            <a:off x="10029825" y="2952750"/>
+            <a:off x="10029825" y="2638425"/>
             <a:ext cx="561975" cy="9525"/>
           </a:xfrm>
           <a:prstGeom xmlns:a="http://schemas.openxmlformats.org/drawingml/2006/main" prst="line">
@@ -2480,10 +2422,10 @@
       </p:sp>
       <p:sp>
         <p:nvSpPr>
-          <p:cNvPr id="37" name="social-ledger-check-3-circle">
-            <a:extLst xmlns:a="http://schemas.openxmlformats.org/drawingml/2006/main">
-              <a:ext uri="{FF2B5EF4-FFF2-40B4-BE49-F238E27FC236}">
-                <a16:creationId xmlns:a16="http://schemas.microsoft.com/office/drawing/2014/main" id="{DB8F5A6F-56C3-45EC-AEBC-3FEA509CE273}"/>
+          <p:cNvPr id="36" name="social-ledger-check-3-circle">
+            <a:extLst xmlns:a="http://schemas.openxmlformats.org/drawingml/2006/main">
+              <a:ext uri="{FF2B5EF4-FFF2-40B4-BE49-F238E27FC236}">
+                <a16:creationId xmlns:a16="http://schemas.microsoft.com/office/drawing/2014/main" id="{44A53FBB-60F6-44B7-9826-18AD40C7B3BC}"/>
               </a:ext>
             </a:extLst>
           </p:cNvPr>
@@ -2494,7 +2436,7 @@
         </p:nvSpPr>
         <p:spPr>
           <a:xfrm xmlns:a="http://schemas.openxmlformats.org/drawingml/2006/main" rot="0">
-            <a:off x="9753600" y="3228975"/>
+            <a:off x="9753600" y="2914650"/>
             <a:ext cx="190500" cy="190500"/>
           </a:xfrm>
           <a:prstGeom xmlns:a="http://schemas.openxmlformats.org/drawingml/2006/main" prst="ellipse">
@@ -2513,10 +2455,10 @@
       </p:sp>
       <p:sp>
         <p:nvSpPr>
-          <p:cNvPr id="38" name="social-ledger-check-3-left">
-            <a:extLst xmlns:a="http://schemas.openxmlformats.org/drawingml/2006/main">
-              <a:ext uri="{FF2B5EF4-FFF2-40B4-BE49-F238E27FC236}">
-                <a16:creationId xmlns:a16="http://schemas.microsoft.com/office/drawing/2014/main" id="{7AFD6C91-4D09-4A75-9755-484F95470901}"/>
+          <p:cNvPr id="37" name="social-ledger-check-3-left">
+            <a:extLst xmlns:a="http://schemas.openxmlformats.org/drawingml/2006/main">
+              <a:ext uri="{FF2B5EF4-FFF2-40B4-BE49-F238E27FC236}">
+                <a16:creationId xmlns:a16="http://schemas.microsoft.com/office/drawing/2014/main" id="{BEFDE19A-1455-4367-B6EC-2599F8DCF8C8}"/>
               </a:ext>
             </a:extLst>
           </p:cNvPr>
@@ -2527,7 +2469,7 @@
         </p:nvSpPr>
         <p:spPr>
           <a:xfrm xmlns:a="http://schemas.openxmlformats.org/drawingml/2006/main" flipH="0" flipV="0">
-            <a:off x="9801225" y="3324225"/>
+            <a:off x="9801225" y="3009900"/>
             <a:ext cx="38100" cy="38100"/>
           </a:xfrm>
           <a:prstGeom xmlns:a="http://schemas.openxmlformats.org/drawingml/2006/main" prst="line">
@@ -2544,10 +2486,10 @@
       </p:sp>
       <p:sp>
         <p:nvSpPr>
-          <p:cNvPr id="39" name="social-ledger-check-3-right">
-            <a:extLst xmlns:a="http://schemas.openxmlformats.org/drawingml/2006/main">
-              <a:ext uri="{FF2B5EF4-FFF2-40B4-BE49-F238E27FC236}">
-                <a16:creationId xmlns:a16="http://schemas.microsoft.com/office/drawing/2014/main" id="{A8FFC33F-47CB-4F6D-831D-668610019BF7}"/>
+          <p:cNvPr id="38" name="social-ledger-check-3-right">
+            <a:extLst xmlns:a="http://schemas.openxmlformats.org/drawingml/2006/main">
+              <a:ext uri="{FF2B5EF4-FFF2-40B4-BE49-F238E27FC236}">
+                <a16:creationId xmlns:a16="http://schemas.microsoft.com/office/drawing/2014/main" id="{1FBD93CA-C680-43DA-A615-1190B30793DE}"/>
               </a:ext>
             </a:extLst>
           </p:cNvPr>
@@ -2558,7 +2500,7 @@
         </p:nvSpPr>
         <p:spPr>
           <a:xfrm xmlns:a="http://schemas.openxmlformats.org/drawingml/2006/main" flipH="0" flipV="1">
-            <a:off x="9839325" y="3286125"/>
+            <a:off x="9839325" y="2971800"/>
             <a:ext cx="66675" cy="76200"/>
           </a:xfrm>
           <a:prstGeom xmlns:a="http://schemas.openxmlformats.org/drawingml/2006/main" prst="line">
@@ -2575,10 +2517,10 @@
       </p:sp>
       <p:sp>
         <p:nvSpPr>
-          <p:cNvPr id="40" name="social-ledger-line-3">
-            <a:extLst xmlns:a="http://schemas.openxmlformats.org/drawingml/2006/main">
-              <a:ext uri="{FF2B5EF4-FFF2-40B4-BE49-F238E27FC236}">
-                <a16:creationId xmlns:a16="http://schemas.microsoft.com/office/drawing/2014/main" id="{CBC1DF36-3EEB-4E13-AD90-4266B4622C47}"/>
+          <p:cNvPr id="39" name="social-ledger-line-3">
+            <a:extLst xmlns:a="http://schemas.openxmlformats.org/drawingml/2006/main">
+              <a:ext uri="{FF2B5EF4-FFF2-40B4-BE49-F238E27FC236}">
+                <a16:creationId xmlns:a16="http://schemas.microsoft.com/office/drawing/2014/main" id="{4A2FA8D4-A4D2-46F5-B208-A285C45BDB1B}"/>
               </a:ext>
             </a:extLst>
           </p:cNvPr>
@@ -2589,7 +2531,7 @@
         </p:nvSpPr>
         <p:spPr>
           <a:xfrm xmlns:a="http://schemas.openxmlformats.org/drawingml/2006/main" flipH="0" flipV="0">
-            <a:off x="10029825" y="3324225"/>
+            <a:off x="10029825" y="3009900"/>
             <a:ext cx="561975" cy="9525"/>
           </a:xfrm>
           <a:prstGeom xmlns:a="http://schemas.openxmlformats.org/drawingml/2006/main" prst="line">
@@ -2606,10 +2548,10 @@
       </p:sp>
       <p:sp>
         <p:nvSpPr>
-          <p:cNvPr id="41" name="social-candidates-label">
-            <a:extLst xmlns:a="http://schemas.openxmlformats.org/drawingml/2006/main">
-              <a:ext uri="{FF2B5EF4-FFF2-40B4-BE49-F238E27FC236}">
-                <a16:creationId xmlns:a16="http://schemas.microsoft.com/office/drawing/2014/main" id="{910AF37F-D96D-40C6-8777-0A70D3B19C7D}"/>
+          <p:cNvPr id="40" name="social-candidates-label">
+            <a:extLst xmlns:a="http://schemas.openxmlformats.org/drawingml/2006/main">
+              <a:ext uri="{FF2B5EF4-FFF2-40B4-BE49-F238E27FC236}">
+                <a16:creationId xmlns:a16="http://schemas.microsoft.com/office/drawing/2014/main" id="{DF80B07F-FF72-44EF-93EB-22A87C607757}"/>
               </a:ext>
             </a:extLst>
           </p:cNvPr>
@@ -2620,7 +2562,7 @@
         </p:nvSpPr>
         <p:spPr>
           <a:xfrm xmlns:a="http://schemas.openxmlformats.org/drawingml/2006/main" rot="0">
-            <a:off x="6705600" y="3790950"/>
+            <a:off x="6705600" y="3476625"/>
             <a:ext cx="952500" cy="400050"/>
           </a:xfrm>
           <a:prstGeom xmlns:a="http://schemas.openxmlformats.org/drawingml/2006/main" prst="rect">
@@ -2664,10 +2606,10 @@
       </p:sp>
       <p:sp>
         <p:nvSpPr>
-          <p:cNvPr id="42" name="social-queue-label">
-            <a:extLst xmlns:a="http://schemas.openxmlformats.org/drawingml/2006/main">
-              <a:ext uri="{FF2B5EF4-FFF2-40B4-BE49-F238E27FC236}">
-                <a16:creationId xmlns:a16="http://schemas.microsoft.com/office/drawing/2014/main" id="{4716C71A-8218-469C-82C6-A57A2D1AD467}"/>
+          <p:cNvPr id="41" name="social-queue-label">
+            <a:extLst xmlns:a="http://schemas.openxmlformats.org/drawingml/2006/main">
+              <a:ext uri="{FF2B5EF4-FFF2-40B4-BE49-F238E27FC236}">
+                <a16:creationId xmlns:a16="http://schemas.microsoft.com/office/drawing/2014/main" id="{46EF49D1-16EB-4241-93AB-A85A249FF9D8}"/>
               </a:ext>
             </a:extLst>
           </p:cNvPr>
@@ -2678,7 +2620,7 @@
         </p:nvSpPr>
         <p:spPr>
           <a:xfrm xmlns:a="http://schemas.openxmlformats.org/drawingml/2006/main" rot="0">
-            <a:off x="8134350" y="3790950"/>
+            <a:off x="8134350" y="3476625"/>
             <a:ext cx="990600" cy="400050"/>
           </a:xfrm>
           <a:prstGeom xmlns:a="http://schemas.openxmlformats.org/drawingml/2006/main" prst="rect">
@@ -2722,10 +2664,10 @@
       </p:sp>
       <p:sp>
         <p:nvSpPr>
-          <p:cNvPr id="43" name="social-ledger-label">
-            <a:extLst xmlns:a="http://schemas.openxmlformats.org/drawingml/2006/main">
-              <a:ext uri="{FF2B5EF4-FFF2-40B4-BE49-F238E27FC236}">
-                <a16:creationId xmlns:a16="http://schemas.microsoft.com/office/drawing/2014/main" id="{279690F5-585F-4D5C-B256-78BAAFAB96CD}"/>
+          <p:cNvPr id="42" name="social-ledger-label">
+            <a:extLst xmlns:a="http://schemas.openxmlformats.org/drawingml/2006/main">
+              <a:ext uri="{FF2B5EF4-FFF2-40B4-BE49-F238E27FC236}">
+                <a16:creationId xmlns:a16="http://schemas.microsoft.com/office/drawing/2014/main" id="{2D51C24E-DC79-48B9-88F3-64AE90FE4714}"/>
               </a:ext>
             </a:extLst>
           </p:cNvPr>
@@ -2736,7 +2678,7 @@
         </p:nvSpPr>
         <p:spPr>
           <a:xfrm xmlns:a="http://schemas.openxmlformats.org/drawingml/2006/main" rot="0">
-            <a:off x="9601200" y="3790950"/>
+            <a:off x="9601200" y="3476625"/>
             <a:ext cx="1162050" cy="400050"/>
           </a:xfrm>
           <a:prstGeom xmlns:a="http://schemas.openxmlformats.org/drawingml/2006/main" prst="rect">
@@ -2780,10 +2722,10 @@
       </p:sp>
       <p:sp>
         <p:nvSpPr>
-          <p:cNvPr id="44" name="social-method-line">
-            <a:extLst xmlns:a="http://schemas.openxmlformats.org/drawingml/2006/main">
-              <a:ext uri="{FF2B5EF4-FFF2-40B4-BE49-F238E27FC236}">
-                <a16:creationId xmlns:a16="http://schemas.microsoft.com/office/drawing/2014/main" id="{D6677806-C6A4-406D-BEEF-50B6B42CD9C1}"/>
+          <p:cNvPr id="43" name="social-method-line">
+            <a:extLst xmlns:a="http://schemas.openxmlformats.org/drawingml/2006/main">
+              <a:ext uri="{FF2B5EF4-FFF2-40B4-BE49-F238E27FC236}">
+                <a16:creationId xmlns:a16="http://schemas.microsoft.com/office/drawing/2014/main" id="{B4B8E1CE-6398-439B-9030-67EACE48D8DD}"/>
               </a:ext>
             </a:extLst>
           </p:cNvPr>
@@ -2794,7 +2736,7 @@
         </p:nvSpPr>
         <p:spPr>
           <a:xfrm xmlns:a="http://schemas.openxmlformats.org/drawingml/2006/main" rot="0">
-            <a:off x="7458075" y="4495800"/>
+            <a:off x="7458075" y="4171950"/>
             <a:ext cx="2667000" cy="247650"/>
           </a:xfrm>
           <a:prstGeom xmlns:a="http://schemas.openxmlformats.org/drawingml/2006/main" prst="rect">
@@ -2808,7 +2750,7 @@
         </p:spPr>
         <p:txBody>
           <a:bodyPr xmlns:a="http://schemas.openxmlformats.org/drawingml/2006/main" wrap="square" lIns="19050" tIns="9525" rIns="19050" bIns="9525" anchor="ctr">
-            <a:normAutofit fontScale="96259"/>
+            <a:normAutofit fontScale="100000"/>
           </a:bodyPr>
           <a:lstStyle xmlns:a="http://schemas.openxmlformats.org/drawingml/2006/main"/>
           <a:p xmlns:a="http://schemas.openxmlformats.org/drawingml/2006/main">
@@ -2817,9 +2759,9 @@
                 <a:solidFill>
                   <a:srgbClr val="637077"/>
                 </a:solidFill>
-                <a:latin typeface="Courier New"/>
-                <a:ea typeface="Courier New"/>
-                <a:cs typeface="Courier New"/>
+                <a:latin typeface="Arial"/>
+                <a:ea typeface="Arial"/>
+                <a:cs typeface="Arial"/>
               </a:defRPr>
             </a:pPr>
             <a:r>
@@ -2827,9 +2769,9 @@
                 <a:solidFill>
                   <a:srgbClr val="637077"/>
                 </a:solidFill>
-                <a:latin typeface="Courier New"/>
-                <a:ea typeface="Courier New"/>
-                <a:cs typeface="Courier New"/>
+                <a:latin typeface="Arial"/>
+                <a:ea typeface="Arial"/>
+                <a:cs typeface="Arial"/>
               </a:rPr>
               <a:t>reserve -&gt; deduplicate -&gt; fill</a:t>
             </a:r>
@@ -2838,10 +2780,10 @@
       </p:sp>
       <p:sp>
         <p:nvSpPr>
-          <p:cNvPr id="45" name="social-footer-divider">
-            <a:extLst xmlns:a="http://schemas.openxmlformats.org/drawingml/2006/main">
-              <a:ext uri="{FF2B5EF4-FFF2-40B4-BE49-F238E27FC236}">
-                <a16:creationId xmlns:a16="http://schemas.microsoft.com/office/drawing/2014/main" id="{60929B51-16D2-40F8-89EE-A85275317F1C}"/>
+          <p:cNvPr id="44" name="social-footer-divider">
+            <a:extLst xmlns:a="http://schemas.openxmlformats.org/drawingml/2006/main">
+              <a:ext uri="{FF2B5EF4-FFF2-40B4-BE49-F238E27FC236}">
+                <a16:creationId xmlns:a16="http://schemas.microsoft.com/office/drawing/2014/main" id="{8C22B69C-BCD0-4B43-A494-2697ACD93925}"/>
               </a:ext>
             </a:extLst>
           </p:cNvPr>
@@ -2852,7 +2794,7 @@
         </p:nvSpPr>
         <p:spPr>
           <a:xfrm xmlns:a="http://schemas.openxmlformats.org/drawingml/2006/main" flipH="0" flipV="0">
-            <a:off x="666750" y="4953000"/>
+            <a:off x="666750" y="4572000"/>
             <a:ext cx="4895850" cy="9525"/>
           </a:xfrm>
           <a:prstGeom xmlns:a="http://schemas.openxmlformats.org/drawingml/2006/main" prst="line">
@@ -2869,10 +2811,10 @@
       </p:sp>
       <p:sp>
         <p:nvSpPr>
-          <p:cNvPr id="46" name="social-contract-line">
-            <a:extLst xmlns:a="http://schemas.openxmlformats.org/drawingml/2006/main">
-              <a:ext uri="{FF2B5EF4-FFF2-40B4-BE49-F238E27FC236}">
-                <a16:creationId xmlns:a16="http://schemas.microsoft.com/office/drawing/2014/main" id="{922982C3-1D5E-444A-82E3-DADF185ECB76}"/>
+          <p:cNvPr id="45" name="social-contract-line">
+            <a:extLst xmlns:a="http://schemas.openxmlformats.org/drawingml/2006/main">
+              <a:ext uri="{FF2B5EF4-FFF2-40B4-BE49-F238E27FC236}">
+                <a16:creationId xmlns:a16="http://schemas.microsoft.com/office/drawing/2014/main" id="{7A37CE54-4639-428B-B4BE-D6606F24A1A4}"/>
               </a:ext>
             </a:extLst>
           </p:cNvPr>
@@ -2883,7 +2825,7 @@
         </p:nvSpPr>
         <p:spPr>
           <a:xfrm xmlns:a="http://schemas.openxmlformats.org/drawingml/2006/main" rot="0">
-            <a:off x="666750" y="5124450"/>
+            <a:off x="666750" y="4743450"/>
             <a:ext cx="5334000" cy="266700"/>
           </a:xfrm>
           <a:prstGeom xmlns:a="http://schemas.openxmlformats.org/drawingml/2006/main" prst="rect">
@@ -2920,7 +2862,7 @@
                 <a:ea typeface="Arial"/>
                 <a:cs typeface="Arial"/>
               </a:rPr>
-              <a:t>Stable ties  |  Fixed capacity  |  Explicit reserves  |  Audit ledger</a:t>
+              <a:t>Stable ties | Fixed capacity | Explicit reserves | Audit ledger</a:t>
             </a:r>
           </a:p>
         </p:txBody>
@@ -2928,7 +2870,7 @@
     </p:spTree>
     <p:extLst>
       <p:ext uri="{BB962C8B-B14F-4D97-AF65-F5344CB8AC3E}">
-        <p14:creationId xmlns:p14="http://schemas.microsoft.com/office/powerpoint/2010/main" val="1542065122"/>
+        <p14:creationId xmlns:p14="http://schemas.microsoft.com/office/powerpoint/2010/main" val="2738473"/>
       </p:ext>
     </p:extLst>
   </p:cSld>

</xml_diff>